<commit_message>
docs: designate the canonical review deck
Link the newest evidence presentation from the root review map, label older decks as design-history snapshots, and replace the stale slide-one source with the current business-extension ADR. Rebuild and visually verify the canonical PPTX without changing its slide content.
</commit_message>
<xml_diff>
--- a/docs/presentation/siemens-senior-ai-engineer-overview.pptx
+++ b/docs/presentation/siemens-senior-ai-engineer-overview.pptx
@@ -2,24 +2,24 @@
 <file path=ppt/presentation.xml><?xml version="1.0" encoding="utf-8"?>
 <p:presentation xmlns:p="http://schemas.openxmlformats.org/presentationml/2006/main">
   <p:sldMasterIdLst>
-    <p:sldMasterId xmlns:r="http://schemas.openxmlformats.org/officeDocument/2006/relationships" id="2147483648" r:id="Re0732fc8304c4410"/>
+    <p:sldMasterId xmlns:r="http://schemas.openxmlformats.org/officeDocument/2006/relationships" id="2147483648" r:id="Rff3353978808434c"/>
   </p:sldMasterIdLst>
   <p:notesMasterIdLst>
-    <p:notesMasterId xmlns:r="http://schemas.openxmlformats.org/officeDocument/2006/relationships" r:id="Rf6df5b5652754d3f"/>
+    <p:notesMasterId xmlns:r="http://schemas.openxmlformats.org/officeDocument/2006/relationships" r:id="Ra3d0f6e1e5e04fc4"/>
   </p:notesMasterIdLst>
   <p:sldIdLst>
-    <p:sldId xmlns:r="http://schemas.openxmlformats.org/officeDocument/2006/relationships" id="256" r:id="Rd4da2411173e44ab"/>
-    <p:sldId xmlns:r="http://schemas.openxmlformats.org/officeDocument/2006/relationships" id="257" r:id="R6b4fc24a19b540da"/>
-    <p:sldId xmlns:r="http://schemas.openxmlformats.org/officeDocument/2006/relationships" id="258" r:id="R508ee1b6a45e4df3"/>
-    <p:sldId xmlns:r="http://schemas.openxmlformats.org/officeDocument/2006/relationships" id="259" r:id="R8698431950094115"/>
-    <p:sldId xmlns:r="http://schemas.openxmlformats.org/officeDocument/2006/relationships" id="260" r:id="R158880f371fe4ce9"/>
-    <p:sldId xmlns:r="http://schemas.openxmlformats.org/officeDocument/2006/relationships" id="261" r:id="R49859d6139e840d2"/>
-    <p:sldId xmlns:r="http://schemas.openxmlformats.org/officeDocument/2006/relationships" id="262" r:id="Ra010c59e10474751"/>
-    <p:sldId xmlns:r="http://schemas.openxmlformats.org/officeDocument/2006/relationships" id="263" r:id="R7ee3556b4e0c4337"/>
-    <p:sldId xmlns:r="http://schemas.openxmlformats.org/officeDocument/2006/relationships" id="264" r:id="Rcb785c2a596445c3"/>
-    <p:sldId xmlns:r="http://schemas.openxmlformats.org/officeDocument/2006/relationships" id="265" r:id="R55d3d5dc0c3e469b"/>
-    <p:sldId xmlns:r="http://schemas.openxmlformats.org/officeDocument/2006/relationships" id="266" r:id="R6f611b8740614c61"/>
-    <p:sldId xmlns:r="http://schemas.openxmlformats.org/officeDocument/2006/relationships" id="267" r:id="R5b626d4803de4eaf"/>
+    <p:sldId xmlns:r="http://schemas.openxmlformats.org/officeDocument/2006/relationships" id="256" r:id="Rd2c5d73131ad4812"/>
+    <p:sldId xmlns:r="http://schemas.openxmlformats.org/officeDocument/2006/relationships" id="257" r:id="R7b14038727fa4049"/>
+    <p:sldId xmlns:r="http://schemas.openxmlformats.org/officeDocument/2006/relationships" id="258" r:id="R20c61ad3860a4779"/>
+    <p:sldId xmlns:r="http://schemas.openxmlformats.org/officeDocument/2006/relationships" id="259" r:id="R4e15e62c16174a79"/>
+    <p:sldId xmlns:r="http://schemas.openxmlformats.org/officeDocument/2006/relationships" id="260" r:id="R0276b9c58587480e"/>
+    <p:sldId xmlns:r="http://schemas.openxmlformats.org/officeDocument/2006/relationships" id="261" r:id="Rd45130ded80144d9"/>
+    <p:sldId xmlns:r="http://schemas.openxmlformats.org/officeDocument/2006/relationships" id="262" r:id="R58acabc45c8d471c"/>
+    <p:sldId xmlns:r="http://schemas.openxmlformats.org/officeDocument/2006/relationships" id="263" r:id="R7512c748d2bb4354"/>
+    <p:sldId xmlns:r="http://schemas.openxmlformats.org/officeDocument/2006/relationships" id="264" r:id="Rab5eaa648fa04803"/>
+    <p:sldId xmlns:r="http://schemas.openxmlformats.org/officeDocument/2006/relationships" id="265" r:id="R3a0207bfcdc146a0"/>
+    <p:sldId xmlns:r="http://schemas.openxmlformats.org/officeDocument/2006/relationships" id="266" r:id="Rdff713f51c604c92"/>
+    <p:sldId xmlns:r="http://schemas.openxmlformats.org/officeDocument/2006/relationships" id="267" r:id="R33376decafc54835"/>
   </p:sldIdLst>
   <p:sldSz cx="12192000" cy="6858000"/>
   <p:notesSz cx="6858000" cy="9144000"/>
@@ -463,7 +463,7 @@
           </a:p>
           <a:p xmlns:a="http://schemas.openxmlformats.org/drawingml/2006/main">
             <a:r>
-              <a:t>- docs/extension-scope-freeze.md</a:t>
+              <a:t>- docs/adr/0007-business-extension-boundaries.md</a:t>
             </a:r>
           </a:p>
         </p:txBody>
@@ -1441,7 +1441,7 @@
   </p:cSld>
   <p:clrMap bg1="lt1" tx1="dk1" bg2="lt2" tx2="dk2" accent1="accent1" accent2="accent2" accent3="accent3" accent4="accent4" accent5="accent5" accent6="accent6" hlink="hlink" folHlink="folHlink"/>
   <p:sldLayoutIdLst>
-    <p:sldLayoutId xmlns:r="http://schemas.openxmlformats.org/officeDocument/2006/relationships" id="2147483649" r:id="R7c82d0fc7f8b4d54"/>
+    <p:sldLayoutId xmlns:r="http://schemas.openxmlformats.org/officeDocument/2006/relationships" id="2147483649" r:id="R11f7b01590184aee"/>
   </p:sldLayoutIdLst>
   <p:txStyles>
     <p:titleStyle>
@@ -1992,7 +1992,7 @@
           <p:cNvPr id="5" name="">
             <a:extLst xmlns:a="http://schemas.openxmlformats.org/drawingml/2006/main">
               <a:ext uri="{FF2B5EF4-FFF2-40B4-BE49-F238E27FC236}">
-                <a16:creationId xmlns:a16="http://schemas.microsoft.com/office/drawing/2014/main" id="{6EE4C4B6-2675-43EC-9CE5-D396C69B3304}"/>
+                <a16:creationId xmlns:a16="http://schemas.microsoft.com/office/drawing/2014/main" id="{EAA014EE-C188-447F-B1B4-02A721694EC0}"/>
               </a:ext>
             </a:extLst>
           </p:cNvPr>
@@ -2050,7 +2050,7 @@
           <p:cNvPr id="2" name="">
             <a:extLst xmlns:a="http://schemas.openxmlformats.org/drawingml/2006/main">
               <a:ext uri="{FF2B5EF4-FFF2-40B4-BE49-F238E27FC236}">
-                <a16:creationId xmlns:a16="http://schemas.microsoft.com/office/drawing/2014/main" id="{9BF8BEDF-7364-449D-BD04-387847479DA7}"/>
+                <a16:creationId xmlns:a16="http://schemas.microsoft.com/office/drawing/2014/main" id="{10F508A2-8334-4C67-8D2C-A84A1EBC7DE9}"/>
               </a:ext>
             </a:extLst>
           </p:cNvPr>
@@ -2131,7 +2131,7 @@
           <p:cNvPr id="3" name="">
             <a:extLst xmlns:a="http://schemas.openxmlformats.org/drawingml/2006/main">
               <a:ext uri="{FF2B5EF4-FFF2-40B4-BE49-F238E27FC236}">
-                <a16:creationId xmlns:a16="http://schemas.microsoft.com/office/drawing/2014/main" id="{D7FC796A-B0EA-4E35-B872-DC79ECDBF5CB}"/>
+                <a16:creationId xmlns:a16="http://schemas.microsoft.com/office/drawing/2014/main" id="{AB86148F-CFC7-436F-AE49-8DED99EB0E91}"/>
               </a:ext>
             </a:extLst>
           </p:cNvPr>
@@ -2164,7 +2164,7 @@
           <p:cNvPr id="4" name="">
             <a:extLst xmlns:a="http://schemas.openxmlformats.org/drawingml/2006/main">
               <a:ext uri="{FF2B5EF4-FFF2-40B4-BE49-F238E27FC236}">
-                <a16:creationId xmlns:a16="http://schemas.microsoft.com/office/drawing/2014/main" id="{A084163A-4DAC-4044-99AA-776A405B2A06}"/>
+                <a16:creationId xmlns:a16="http://schemas.microsoft.com/office/drawing/2014/main" id="{D71A6C75-BF35-4BC5-8362-5780A8A6C94C}"/>
               </a:ext>
             </a:extLst>
           </p:cNvPr>
@@ -2220,7 +2220,7 @@
     </p:spTree>
     <p:extLst>
       <p:ext uri="{BB962C8B-B14F-4D97-AF65-F5344CB8AC3E}">
-        <p14:creationId xmlns:p14="http://schemas.microsoft.com/office/powerpoint/2010/main" val="1069823387"/>
+        <p14:creationId xmlns:p14="http://schemas.microsoft.com/office/powerpoint/2010/main" val="1547980825"/>
       </p:ext>
     </p:extLst>
   </p:cSld>
@@ -2255,7 +2255,7 @@
           <p:nvPr/>
         </p:nvPicPr>
         <p:blipFill>
-          <a:blip xmlns:r="http://schemas.openxmlformats.org/officeDocument/2006/relationships" xmlns:a="http://schemas.openxmlformats.org/drawingml/2006/main" r:embed="Rfd9f3ac50bb540c8"/>
+          <a:blip xmlns:r="http://schemas.openxmlformats.org/officeDocument/2006/relationships" xmlns:a="http://schemas.openxmlformats.org/drawingml/2006/main" r:embed="R361cb002ef1848a4"/>
           <a:stretch xmlns:a="http://schemas.openxmlformats.org/drawingml/2006/main"/>
         </p:blipFill>
         <p:spPr>
@@ -2273,7 +2273,7 @@
           <p:cNvPr id="2" name="">
             <a:extLst xmlns:a="http://schemas.openxmlformats.org/drawingml/2006/main">
               <a:ext uri="{FF2B5EF4-FFF2-40B4-BE49-F238E27FC236}">
-                <a16:creationId xmlns:a16="http://schemas.microsoft.com/office/drawing/2014/main" id="{F13CEC63-AC62-4B03-9341-8BB7143742C7}"/>
+                <a16:creationId xmlns:a16="http://schemas.microsoft.com/office/drawing/2014/main" id="{3B8E31B9-CA23-4F5C-9F62-1752ED668764}"/>
               </a:ext>
             </a:extLst>
           </p:cNvPr>
@@ -2329,7 +2329,7 @@
     </p:spTree>
     <p:extLst>
       <p:ext uri="{BB962C8B-B14F-4D97-AF65-F5344CB8AC3E}">
-        <p14:creationId xmlns:p14="http://schemas.microsoft.com/office/powerpoint/2010/main" val="1735083639"/>
+        <p14:creationId xmlns:p14="http://schemas.microsoft.com/office/powerpoint/2010/main" val="526369665"/>
       </p:ext>
     </p:extLst>
   </p:cSld>
@@ -2360,7 +2360,7 @@
           <p:cNvPr id="18" name="">
             <a:extLst xmlns:a="http://schemas.openxmlformats.org/drawingml/2006/main">
               <a:ext uri="{FF2B5EF4-FFF2-40B4-BE49-F238E27FC236}">
-                <a16:creationId xmlns:a16="http://schemas.microsoft.com/office/drawing/2014/main" id="{A13AE717-5381-4063-8401-2A5DDD9D3B50}"/>
+                <a16:creationId xmlns:a16="http://schemas.microsoft.com/office/drawing/2014/main" id="{48389FC9-CB46-45AC-AF62-0436595164E1}"/>
               </a:ext>
             </a:extLst>
           </p:cNvPr>
@@ -2418,7 +2418,7 @@
           <p:cNvPr id="2" name="">
             <a:extLst xmlns:a="http://schemas.openxmlformats.org/drawingml/2006/main">
               <a:ext uri="{FF2B5EF4-FFF2-40B4-BE49-F238E27FC236}">
-                <a16:creationId xmlns:a16="http://schemas.microsoft.com/office/drawing/2014/main" id="{BC238E6E-9FC8-4559-B6AC-E2F04790E8B2}"/>
+                <a16:creationId xmlns:a16="http://schemas.microsoft.com/office/drawing/2014/main" id="{B11C2D2D-7217-4F37-A689-92216711A5BE}"/>
               </a:ext>
             </a:extLst>
           </p:cNvPr>
@@ -2476,7 +2476,7 @@
           <p:cNvPr id="3" name="">
             <a:extLst xmlns:a="http://schemas.openxmlformats.org/drawingml/2006/main">
               <a:ext uri="{FF2B5EF4-FFF2-40B4-BE49-F238E27FC236}">
-                <a16:creationId xmlns:a16="http://schemas.microsoft.com/office/drawing/2014/main" id="{8545C999-9EAC-4090-9150-A1DD105946DA}"/>
+                <a16:creationId xmlns:a16="http://schemas.microsoft.com/office/drawing/2014/main" id="{A83D0F50-7F36-4FF0-ACCA-95625AE46415}"/>
               </a:ext>
             </a:extLst>
           </p:cNvPr>
@@ -2534,7 +2534,7 @@
           <p:cNvPr id="4" name="">
             <a:extLst xmlns:a="http://schemas.openxmlformats.org/drawingml/2006/main">
               <a:ext uri="{FF2B5EF4-FFF2-40B4-BE49-F238E27FC236}">
-                <a16:creationId xmlns:a16="http://schemas.microsoft.com/office/drawing/2014/main" id="{957108D6-8E68-4099-A150-E9CF5F9F470F}"/>
+                <a16:creationId xmlns:a16="http://schemas.microsoft.com/office/drawing/2014/main" id="{DDA970CE-B508-4F16-9D68-507F4C8155A9}"/>
               </a:ext>
             </a:extLst>
           </p:cNvPr>
@@ -2592,7 +2592,7 @@
           <p:cNvPr id="5" name="">
             <a:extLst xmlns:a="http://schemas.openxmlformats.org/drawingml/2006/main">
               <a:ext uri="{FF2B5EF4-FFF2-40B4-BE49-F238E27FC236}">
-                <a16:creationId xmlns:a16="http://schemas.microsoft.com/office/drawing/2014/main" id="{E37E6A84-419C-4DA9-9E78-65D285B16FB4}"/>
+                <a16:creationId xmlns:a16="http://schemas.microsoft.com/office/drawing/2014/main" id="{724E3DC0-C376-471A-89A8-B610CC1F110F}"/>
               </a:ext>
             </a:extLst>
           </p:cNvPr>
@@ -2650,7 +2650,7 @@
           <p:cNvPr id="6" name="">
             <a:extLst xmlns:a="http://schemas.openxmlformats.org/drawingml/2006/main">
               <a:ext uri="{FF2B5EF4-FFF2-40B4-BE49-F238E27FC236}">
-                <a16:creationId xmlns:a16="http://schemas.microsoft.com/office/drawing/2014/main" id="{6AC18E79-3505-43A0-BB68-7346278D3622}"/>
+                <a16:creationId xmlns:a16="http://schemas.microsoft.com/office/drawing/2014/main" id="{66C5BA5B-2098-4EED-BFA2-8FCF5EC46612}"/>
               </a:ext>
             </a:extLst>
           </p:cNvPr>
@@ -2708,7 +2708,7 @@
           <p:cNvPr id="7" name="">
             <a:extLst xmlns:a="http://schemas.openxmlformats.org/drawingml/2006/main">
               <a:ext uri="{FF2B5EF4-FFF2-40B4-BE49-F238E27FC236}">
-                <a16:creationId xmlns:a16="http://schemas.microsoft.com/office/drawing/2014/main" id="{E1EF8EC8-C17F-485D-ABF2-B0BE84C8D2FF}"/>
+                <a16:creationId xmlns:a16="http://schemas.microsoft.com/office/drawing/2014/main" id="{0FA0BB30-A95D-4D02-9E9B-E2761260B2C8}"/>
               </a:ext>
             </a:extLst>
           </p:cNvPr>
@@ -2766,7 +2766,7 @@
           <p:cNvPr id="8" name="">
             <a:extLst xmlns:a="http://schemas.openxmlformats.org/drawingml/2006/main">
               <a:ext uri="{FF2B5EF4-FFF2-40B4-BE49-F238E27FC236}">
-                <a16:creationId xmlns:a16="http://schemas.microsoft.com/office/drawing/2014/main" id="{49227E1B-10CF-4520-B43C-6242AEFA723F}"/>
+                <a16:creationId xmlns:a16="http://schemas.microsoft.com/office/drawing/2014/main" id="{FA759A00-A685-478C-A086-AD357FBB8425}"/>
               </a:ext>
             </a:extLst>
           </p:cNvPr>
@@ -2824,7 +2824,7 @@
           <p:cNvPr id="9" name="">
             <a:extLst xmlns:a="http://schemas.openxmlformats.org/drawingml/2006/main">
               <a:ext uri="{FF2B5EF4-FFF2-40B4-BE49-F238E27FC236}">
-                <a16:creationId xmlns:a16="http://schemas.microsoft.com/office/drawing/2014/main" id="{D8C16692-F45F-4480-A7F1-55320AD77E2C}"/>
+                <a16:creationId xmlns:a16="http://schemas.microsoft.com/office/drawing/2014/main" id="{9E8024C7-8ECC-46E9-94C9-9982CFC578C8}"/>
               </a:ext>
             </a:extLst>
           </p:cNvPr>
@@ -2882,7 +2882,7 @@
           <p:cNvPr id="10" name="">
             <a:extLst xmlns:a="http://schemas.openxmlformats.org/drawingml/2006/main">
               <a:ext uri="{FF2B5EF4-FFF2-40B4-BE49-F238E27FC236}">
-                <a16:creationId xmlns:a16="http://schemas.microsoft.com/office/drawing/2014/main" id="{425890A4-DF27-4B12-825B-6A8E8A3385D0}"/>
+                <a16:creationId xmlns:a16="http://schemas.microsoft.com/office/drawing/2014/main" id="{8BE9A3FE-8ACC-4CDD-8464-E9755C68B3F2}"/>
               </a:ext>
             </a:extLst>
           </p:cNvPr>
@@ -2915,7 +2915,7 @@
           <p:cNvPr id="11" name="">
             <a:extLst xmlns:a="http://schemas.openxmlformats.org/drawingml/2006/main">
               <a:ext uri="{FF2B5EF4-FFF2-40B4-BE49-F238E27FC236}">
-                <a16:creationId xmlns:a16="http://schemas.microsoft.com/office/drawing/2014/main" id="{151312F3-D586-496F-9BBA-7E5E9799BA83}"/>
+                <a16:creationId xmlns:a16="http://schemas.microsoft.com/office/drawing/2014/main" id="{F7E76F1E-CC6E-4CA9-B5BC-24C8AA39D03F}"/>
               </a:ext>
             </a:extLst>
           </p:cNvPr>
@@ -2973,7 +2973,7 @@
           <p:cNvPr id="12" name="">
             <a:extLst xmlns:a="http://schemas.openxmlformats.org/drawingml/2006/main">
               <a:ext uri="{FF2B5EF4-FFF2-40B4-BE49-F238E27FC236}">
-                <a16:creationId xmlns:a16="http://schemas.microsoft.com/office/drawing/2014/main" id="{16A90908-BA40-447F-9F9F-7E302B4125A8}"/>
+                <a16:creationId xmlns:a16="http://schemas.microsoft.com/office/drawing/2014/main" id="{4B3D0E81-00DE-4A29-8DE1-006DBA9272BB}"/>
               </a:ext>
             </a:extLst>
           </p:cNvPr>
@@ -3031,7 +3031,7 @@
           <p:cNvPr id="13" name="">
             <a:extLst xmlns:a="http://schemas.openxmlformats.org/drawingml/2006/main">
               <a:ext uri="{FF2B5EF4-FFF2-40B4-BE49-F238E27FC236}">
-                <a16:creationId xmlns:a16="http://schemas.microsoft.com/office/drawing/2014/main" id="{F148896B-9B8F-4041-8A05-F19061B1FC09}"/>
+                <a16:creationId xmlns:a16="http://schemas.microsoft.com/office/drawing/2014/main" id="{5459CEC1-2D7B-4AA6-A418-025EC3128DC7}"/>
               </a:ext>
             </a:extLst>
           </p:cNvPr>
@@ -3089,7 +3089,7 @@
           <p:cNvPr id="14" name="">
             <a:extLst xmlns:a="http://schemas.openxmlformats.org/drawingml/2006/main">
               <a:ext uri="{FF2B5EF4-FFF2-40B4-BE49-F238E27FC236}">
-                <a16:creationId xmlns:a16="http://schemas.microsoft.com/office/drawing/2014/main" id="{C419FE13-DC1D-49FC-A59D-2A8799713F0A}"/>
+                <a16:creationId xmlns:a16="http://schemas.microsoft.com/office/drawing/2014/main" id="{32C48AE7-9D87-4C76-A425-75E3FD435FF6}"/>
               </a:ext>
             </a:extLst>
           </p:cNvPr>
@@ -3147,7 +3147,7 @@
           <p:cNvPr id="15" name="">
             <a:extLst xmlns:a="http://schemas.openxmlformats.org/drawingml/2006/main">
               <a:ext uri="{FF2B5EF4-FFF2-40B4-BE49-F238E27FC236}">
-                <a16:creationId xmlns:a16="http://schemas.microsoft.com/office/drawing/2014/main" id="{7D77CDCF-7E41-4908-B128-A277FE601E19}"/>
+                <a16:creationId xmlns:a16="http://schemas.microsoft.com/office/drawing/2014/main" id="{E717A913-2E96-4FBA-AED2-33F34F59CE2E}"/>
               </a:ext>
             </a:extLst>
           </p:cNvPr>
@@ -3205,7 +3205,7 @@
           <p:cNvPr id="16" name="">
             <a:extLst xmlns:a="http://schemas.openxmlformats.org/drawingml/2006/main">
               <a:ext uri="{FF2B5EF4-FFF2-40B4-BE49-F238E27FC236}">
-                <a16:creationId xmlns:a16="http://schemas.microsoft.com/office/drawing/2014/main" id="{752C8106-A2A1-467E-9CD6-CDBA313B20CE}"/>
+                <a16:creationId xmlns:a16="http://schemas.microsoft.com/office/drawing/2014/main" id="{EC0190D2-EA93-407F-8994-1B7C06B160CB}"/>
               </a:ext>
             </a:extLst>
           </p:cNvPr>
@@ -3263,7 +3263,7 @@
           <p:cNvPr id="17" name="">
             <a:extLst xmlns:a="http://schemas.openxmlformats.org/drawingml/2006/main">
               <a:ext uri="{FF2B5EF4-FFF2-40B4-BE49-F238E27FC236}">
-                <a16:creationId xmlns:a16="http://schemas.microsoft.com/office/drawing/2014/main" id="{526EA82A-5B47-44BE-9A5F-D8692D98D3F0}"/>
+                <a16:creationId xmlns:a16="http://schemas.microsoft.com/office/drawing/2014/main" id="{89C84A6C-07F3-4E84-81F4-C6E047B4E130}"/>
               </a:ext>
             </a:extLst>
           </p:cNvPr>
@@ -3319,7 +3319,7 @@
     </p:spTree>
     <p:extLst>
       <p:ext uri="{BB962C8B-B14F-4D97-AF65-F5344CB8AC3E}">
-        <p14:creationId xmlns:p14="http://schemas.microsoft.com/office/powerpoint/2010/main" val="404617875"/>
+        <p14:creationId xmlns:p14="http://schemas.microsoft.com/office/powerpoint/2010/main" val="812161427"/>
       </p:ext>
     </p:extLst>
   </p:cSld>
@@ -3350,7 +3350,7 @@
           <p:cNvPr id="9" name="">
             <a:extLst xmlns:a="http://schemas.openxmlformats.org/drawingml/2006/main">
               <a:ext uri="{FF2B5EF4-FFF2-40B4-BE49-F238E27FC236}">
-                <a16:creationId xmlns:a16="http://schemas.microsoft.com/office/drawing/2014/main" id="{DB82B7A0-F39A-4E51-B27C-E3C544F59376}"/>
+                <a16:creationId xmlns:a16="http://schemas.microsoft.com/office/drawing/2014/main" id="{8B28340E-16CA-47A6-B0DE-651DF3B19951}"/>
               </a:ext>
             </a:extLst>
           </p:cNvPr>
@@ -3408,7 +3408,7 @@
           <p:cNvPr id="2" name="">
             <a:extLst xmlns:a="http://schemas.openxmlformats.org/drawingml/2006/main">
               <a:ext uri="{FF2B5EF4-FFF2-40B4-BE49-F238E27FC236}">
-                <a16:creationId xmlns:a16="http://schemas.microsoft.com/office/drawing/2014/main" id="{635B33A5-EBDD-4603-ADFA-963C756CB5ED}"/>
+                <a16:creationId xmlns:a16="http://schemas.microsoft.com/office/drawing/2014/main" id="{F3715573-9CF1-4D3D-B42B-B374DCAA8D3C}"/>
               </a:ext>
             </a:extLst>
           </p:cNvPr>
@@ -3489,7 +3489,7 @@
           <p:cNvPr id="3" name="">
             <a:extLst xmlns:a="http://schemas.openxmlformats.org/drawingml/2006/main">
               <a:ext uri="{FF2B5EF4-FFF2-40B4-BE49-F238E27FC236}">
-                <a16:creationId xmlns:a16="http://schemas.microsoft.com/office/drawing/2014/main" id="{67C0663C-1648-4DAC-9E5F-2B525998A06C}"/>
+                <a16:creationId xmlns:a16="http://schemas.microsoft.com/office/drawing/2014/main" id="{2B6C5CF3-1C0E-4C33-8B19-72B030DF846A}"/>
               </a:ext>
             </a:extLst>
           </p:cNvPr>
@@ -3522,7 +3522,7 @@
           <p:cNvPr id="4" name="">
             <a:extLst xmlns:a="http://schemas.openxmlformats.org/drawingml/2006/main">
               <a:ext uri="{FF2B5EF4-FFF2-40B4-BE49-F238E27FC236}">
-                <a16:creationId xmlns:a16="http://schemas.microsoft.com/office/drawing/2014/main" id="{D5F83BC8-AF37-4374-931C-6C701C59638A}"/>
+                <a16:creationId xmlns:a16="http://schemas.microsoft.com/office/drawing/2014/main" id="{99636451-0BBC-497E-87BD-1A4F0BF871EA}"/>
               </a:ext>
             </a:extLst>
           </p:cNvPr>
@@ -3580,7 +3580,7 @@
           <p:cNvPr id="5" name="">
             <a:extLst xmlns:a="http://schemas.openxmlformats.org/drawingml/2006/main">
               <a:ext uri="{FF2B5EF4-FFF2-40B4-BE49-F238E27FC236}">
-                <a16:creationId xmlns:a16="http://schemas.microsoft.com/office/drawing/2014/main" id="{E8FC5513-E9E2-4E6F-87D9-548E8ACADECD}"/>
+                <a16:creationId xmlns:a16="http://schemas.microsoft.com/office/drawing/2014/main" id="{0E2D712F-3819-46A5-BBBD-599116AF5364}"/>
               </a:ext>
             </a:extLst>
           </p:cNvPr>
@@ -3638,7 +3638,7 @@
           <p:cNvPr id="6" name="">
             <a:extLst xmlns:a="http://schemas.openxmlformats.org/drawingml/2006/main">
               <a:ext uri="{FF2B5EF4-FFF2-40B4-BE49-F238E27FC236}">
-                <a16:creationId xmlns:a16="http://schemas.microsoft.com/office/drawing/2014/main" id="{AB57F745-2278-447E-8646-7C13E5AD43C5}"/>
+                <a16:creationId xmlns:a16="http://schemas.microsoft.com/office/drawing/2014/main" id="{E42248DD-3117-49AE-97E5-A869256193DA}"/>
               </a:ext>
             </a:extLst>
           </p:cNvPr>
@@ -3696,7 +3696,7 @@
           <p:cNvPr id="7" name="">
             <a:extLst xmlns:a="http://schemas.openxmlformats.org/drawingml/2006/main">
               <a:ext uri="{FF2B5EF4-FFF2-40B4-BE49-F238E27FC236}">
-                <a16:creationId xmlns:a16="http://schemas.microsoft.com/office/drawing/2014/main" id="{F09277B1-68DF-446E-B561-66093BFA968B}"/>
+                <a16:creationId xmlns:a16="http://schemas.microsoft.com/office/drawing/2014/main" id="{E6B5235F-0355-4390-AF29-0730821EB6EA}"/>
               </a:ext>
             </a:extLst>
           </p:cNvPr>
@@ -3754,7 +3754,7 @@
           <p:cNvPr id="8" name="">
             <a:extLst xmlns:a="http://schemas.openxmlformats.org/drawingml/2006/main">
               <a:ext uri="{FF2B5EF4-FFF2-40B4-BE49-F238E27FC236}">
-                <a16:creationId xmlns:a16="http://schemas.microsoft.com/office/drawing/2014/main" id="{5FD4ED51-7BE6-4325-B6D5-C118C4503B25}"/>
+                <a16:creationId xmlns:a16="http://schemas.microsoft.com/office/drawing/2014/main" id="{664500FB-CA05-49C4-B3A5-D37805846743}"/>
               </a:ext>
             </a:extLst>
           </p:cNvPr>
@@ -3810,7 +3810,7 @@
     </p:spTree>
     <p:extLst>
       <p:ext uri="{BB962C8B-B14F-4D97-AF65-F5344CB8AC3E}">
-        <p14:creationId xmlns:p14="http://schemas.microsoft.com/office/powerpoint/2010/main" val="409463245"/>
+        <p14:creationId xmlns:p14="http://schemas.microsoft.com/office/powerpoint/2010/main" val="1657924763"/>
       </p:ext>
     </p:extLst>
   </p:cSld>
@@ -3841,7 +3841,7 @@
           <p:cNvPr id="18" name="">
             <a:extLst xmlns:a="http://schemas.openxmlformats.org/drawingml/2006/main">
               <a:ext uri="{FF2B5EF4-FFF2-40B4-BE49-F238E27FC236}">
-                <a16:creationId xmlns:a16="http://schemas.microsoft.com/office/drawing/2014/main" id="{6B8BE6E5-DFA7-42B6-903C-DEDD80EF308B}"/>
+                <a16:creationId xmlns:a16="http://schemas.microsoft.com/office/drawing/2014/main" id="{8F206849-06F0-4AF8-B296-8BD0D91D866A}"/>
               </a:ext>
             </a:extLst>
           </p:cNvPr>
@@ -3899,7 +3899,7 @@
           <p:cNvPr id="2" name="">
             <a:extLst xmlns:a="http://schemas.openxmlformats.org/drawingml/2006/main">
               <a:ext uri="{FF2B5EF4-FFF2-40B4-BE49-F238E27FC236}">
-                <a16:creationId xmlns:a16="http://schemas.microsoft.com/office/drawing/2014/main" id="{B1E0B9AF-7B1A-43BC-8609-406798693996}"/>
+                <a16:creationId xmlns:a16="http://schemas.microsoft.com/office/drawing/2014/main" id="{9BBC3EF0-C322-469A-83AE-F382BFA65B48}"/>
               </a:ext>
             </a:extLst>
           </p:cNvPr>
@@ -3957,7 +3957,7 @@
           <p:cNvPr id="3" name="">
             <a:extLst xmlns:a="http://schemas.openxmlformats.org/drawingml/2006/main">
               <a:ext uri="{FF2B5EF4-FFF2-40B4-BE49-F238E27FC236}">
-                <a16:creationId xmlns:a16="http://schemas.microsoft.com/office/drawing/2014/main" id="{EA275A9F-1AB2-4799-860A-242ABB1C68AC}"/>
+                <a16:creationId xmlns:a16="http://schemas.microsoft.com/office/drawing/2014/main" id="{9A084B92-954C-4828-ACF1-F3410B260E0C}"/>
               </a:ext>
             </a:extLst>
           </p:cNvPr>
@@ -4015,7 +4015,7 @@
           <p:cNvPr id="4" name="">
             <a:extLst xmlns:a="http://schemas.openxmlformats.org/drawingml/2006/main">
               <a:ext uri="{FF2B5EF4-FFF2-40B4-BE49-F238E27FC236}">
-                <a16:creationId xmlns:a16="http://schemas.microsoft.com/office/drawing/2014/main" id="{E5D000EF-1E24-468E-9223-639982503C26}"/>
+                <a16:creationId xmlns:a16="http://schemas.microsoft.com/office/drawing/2014/main" id="{7C0DB7CC-74C1-4622-AD3F-2F85B13A9259}"/>
               </a:ext>
             </a:extLst>
           </p:cNvPr>
@@ -4048,7 +4048,7 @@
           <p:cNvPr id="5" name="">
             <a:extLst xmlns:a="http://schemas.openxmlformats.org/drawingml/2006/main">
               <a:ext uri="{FF2B5EF4-FFF2-40B4-BE49-F238E27FC236}">
-                <a16:creationId xmlns:a16="http://schemas.microsoft.com/office/drawing/2014/main" id="{D03195E0-6280-491D-A2F1-78116972A6E4}"/>
+                <a16:creationId xmlns:a16="http://schemas.microsoft.com/office/drawing/2014/main" id="{2BCD3B89-6F8E-4D18-BCB0-286D8DC94C58}"/>
               </a:ext>
             </a:extLst>
           </p:cNvPr>
@@ -4079,7 +4079,7 @@
           <p:cNvPr id="6" name="">
             <a:extLst xmlns:a="http://schemas.openxmlformats.org/drawingml/2006/main">
               <a:ext uri="{FF2B5EF4-FFF2-40B4-BE49-F238E27FC236}">
-                <a16:creationId xmlns:a16="http://schemas.microsoft.com/office/drawing/2014/main" id="{6F08EF5A-EBBF-435F-B1C4-5D14FA431FF1}"/>
+                <a16:creationId xmlns:a16="http://schemas.microsoft.com/office/drawing/2014/main" id="{4139E826-70A2-441B-BA31-EC111A3A5275}"/>
               </a:ext>
             </a:extLst>
           </p:cNvPr>
@@ -4137,7 +4137,7 @@
           <p:cNvPr id="7" name="">
             <a:extLst xmlns:a="http://schemas.openxmlformats.org/drawingml/2006/main">
               <a:ext uri="{FF2B5EF4-FFF2-40B4-BE49-F238E27FC236}">
-                <a16:creationId xmlns:a16="http://schemas.microsoft.com/office/drawing/2014/main" id="{73340098-C652-4484-95C2-795CF77DD496}"/>
+                <a16:creationId xmlns:a16="http://schemas.microsoft.com/office/drawing/2014/main" id="{F045A172-AE36-41F6-BF10-9249365F35C6}"/>
               </a:ext>
             </a:extLst>
           </p:cNvPr>
@@ -4195,7 +4195,7 @@
           <p:cNvPr id="8" name="">
             <a:extLst xmlns:a="http://schemas.openxmlformats.org/drawingml/2006/main">
               <a:ext uri="{FF2B5EF4-FFF2-40B4-BE49-F238E27FC236}">
-                <a16:creationId xmlns:a16="http://schemas.microsoft.com/office/drawing/2014/main" id="{2B6DD99B-81E0-4232-91A1-AFA0925124AE}"/>
+                <a16:creationId xmlns:a16="http://schemas.microsoft.com/office/drawing/2014/main" id="{0E5DA1A4-539E-40C5-ABCB-025D0B874EDE}"/>
               </a:ext>
             </a:extLst>
           </p:cNvPr>
@@ -4276,7 +4276,7 @@
           <p:cNvPr id="9" name="">
             <a:extLst xmlns:a="http://schemas.openxmlformats.org/drawingml/2006/main">
               <a:ext uri="{FF2B5EF4-FFF2-40B4-BE49-F238E27FC236}">
-                <a16:creationId xmlns:a16="http://schemas.microsoft.com/office/drawing/2014/main" id="{7AC2218D-3993-4998-BD3B-4676CF9AC288}"/>
+                <a16:creationId xmlns:a16="http://schemas.microsoft.com/office/drawing/2014/main" id="{C19E4BB8-303C-45DC-A355-3F96B8FB702E}"/>
               </a:ext>
             </a:extLst>
           </p:cNvPr>
@@ -4307,7 +4307,7 @@
           <p:cNvPr id="10" name="">
             <a:extLst xmlns:a="http://schemas.openxmlformats.org/drawingml/2006/main">
               <a:ext uri="{FF2B5EF4-FFF2-40B4-BE49-F238E27FC236}">
-                <a16:creationId xmlns:a16="http://schemas.microsoft.com/office/drawing/2014/main" id="{92C8C1C0-797D-457F-A11F-223391E82AD8}"/>
+                <a16:creationId xmlns:a16="http://schemas.microsoft.com/office/drawing/2014/main" id="{B09CEF67-CAA5-4466-BD58-4187376F2382}"/>
               </a:ext>
             </a:extLst>
           </p:cNvPr>
@@ -4365,7 +4365,7 @@
           <p:cNvPr id="11" name="">
             <a:extLst xmlns:a="http://schemas.openxmlformats.org/drawingml/2006/main">
               <a:ext uri="{FF2B5EF4-FFF2-40B4-BE49-F238E27FC236}">
-                <a16:creationId xmlns:a16="http://schemas.microsoft.com/office/drawing/2014/main" id="{4A1E4691-06BB-4EC0-BA36-830D62916886}"/>
+                <a16:creationId xmlns:a16="http://schemas.microsoft.com/office/drawing/2014/main" id="{A3DA923D-6826-4150-BBDA-0F0668AF3701}"/>
               </a:ext>
             </a:extLst>
           </p:cNvPr>
@@ -4423,7 +4423,7 @@
           <p:cNvPr id="12" name="">
             <a:extLst xmlns:a="http://schemas.openxmlformats.org/drawingml/2006/main">
               <a:ext uri="{FF2B5EF4-FFF2-40B4-BE49-F238E27FC236}">
-                <a16:creationId xmlns:a16="http://schemas.microsoft.com/office/drawing/2014/main" id="{1F7C9EE6-4214-4BF8-9E65-5694E651ABED}"/>
+                <a16:creationId xmlns:a16="http://schemas.microsoft.com/office/drawing/2014/main" id="{EFC329E8-1CAA-4C9F-983A-46DB8CCC5584}"/>
               </a:ext>
             </a:extLst>
           </p:cNvPr>
@@ -4504,7 +4504,7 @@
           <p:cNvPr id="13" name="">
             <a:extLst xmlns:a="http://schemas.openxmlformats.org/drawingml/2006/main">
               <a:ext uri="{FF2B5EF4-FFF2-40B4-BE49-F238E27FC236}">
-                <a16:creationId xmlns:a16="http://schemas.microsoft.com/office/drawing/2014/main" id="{8C4C8024-C727-40DB-B3AE-16343428C11D}"/>
+                <a16:creationId xmlns:a16="http://schemas.microsoft.com/office/drawing/2014/main" id="{531EB538-26D4-4D16-8818-E8DA83D4C5DF}"/>
               </a:ext>
             </a:extLst>
           </p:cNvPr>
@@ -4535,7 +4535,7 @@
           <p:cNvPr id="14" name="">
             <a:extLst xmlns:a="http://schemas.openxmlformats.org/drawingml/2006/main">
               <a:ext uri="{FF2B5EF4-FFF2-40B4-BE49-F238E27FC236}">
-                <a16:creationId xmlns:a16="http://schemas.microsoft.com/office/drawing/2014/main" id="{8ACE70DA-68DC-4E27-9764-C62DBB1D9320}"/>
+                <a16:creationId xmlns:a16="http://schemas.microsoft.com/office/drawing/2014/main" id="{16FD6642-1C35-4355-BBCC-968DA31D0A3D}"/>
               </a:ext>
             </a:extLst>
           </p:cNvPr>
@@ -4593,7 +4593,7 @@
           <p:cNvPr id="15" name="">
             <a:extLst xmlns:a="http://schemas.openxmlformats.org/drawingml/2006/main">
               <a:ext uri="{FF2B5EF4-FFF2-40B4-BE49-F238E27FC236}">
-                <a16:creationId xmlns:a16="http://schemas.microsoft.com/office/drawing/2014/main" id="{D7A0F544-B233-4093-88AD-C4EE9713B05E}"/>
+                <a16:creationId xmlns:a16="http://schemas.microsoft.com/office/drawing/2014/main" id="{4EADE287-B623-4B86-8E9F-F04AAE41BFA4}"/>
               </a:ext>
             </a:extLst>
           </p:cNvPr>
@@ -4651,7 +4651,7 @@
           <p:cNvPr id="16" name="">
             <a:extLst xmlns:a="http://schemas.openxmlformats.org/drawingml/2006/main">
               <a:ext uri="{FF2B5EF4-FFF2-40B4-BE49-F238E27FC236}">
-                <a16:creationId xmlns:a16="http://schemas.microsoft.com/office/drawing/2014/main" id="{7E382507-9FDF-4877-87EB-526916E97786}"/>
+                <a16:creationId xmlns:a16="http://schemas.microsoft.com/office/drawing/2014/main" id="{E721A92C-213B-44FA-A197-2A7623D6631B}"/>
               </a:ext>
             </a:extLst>
           </p:cNvPr>
@@ -4732,7 +4732,7 @@
           <p:cNvPr id="17" name="">
             <a:extLst xmlns:a="http://schemas.openxmlformats.org/drawingml/2006/main">
               <a:ext uri="{FF2B5EF4-FFF2-40B4-BE49-F238E27FC236}">
-                <a16:creationId xmlns:a16="http://schemas.microsoft.com/office/drawing/2014/main" id="{CBD4DAF7-DF97-4702-9544-06DAA5DF0C0B}"/>
+                <a16:creationId xmlns:a16="http://schemas.microsoft.com/office/drawing/2014/main" id="{7B32713C-B61E-4E7B-A9CA-4226EF157779}"/>
               </a:ext>
             </a:extLst>
           </p:cNvPr>
@@ -4788,7 +4788,7 @@
     </p:spTree>
     <p:extLst>
       <p:ext uri="{BB962C8B-B14F-4D97-AF65-F5344CB8AC3E}">
-        <p14:creationId xmlns:p14="http://schemas.microsoft.com/office/powerpoint/2010/main" val="939362292"/>
+        <p14:creationId xmlns:p14="http://schemas.microsoft.com/office/powerpoint/2010/main" val="1931913829"/>
       </p:ext>
     </p:extLst>
   </p:cSld>
@@ -4823,7 +4823,7 @@
           <p:nvPr/>
         </p:nvPicPr>
         <p:blipFill>
-          <a:blip xmlns:r="http://schemas.openxmlformats.org/officeDocument/2006/relationships" xmlns:a="http://schemas.openxmlformats.org/drawingml/2006/main" r:embed="Ree49c891043244c9"/>
+          <a:blip xmlns:r="http://schemas.openxmlformats.org/officeDocument/2006/relationships" xmlns:a="http://schemas.openxmlformats.org/drawingml/2006/main" r:embed="Rd3e6405cb1264646"/>
           <a:stretch xmlns:a="http://schemas.openxmlformats.org/drawingml/2006/main"/>
         </p:blipFill>
         <p:spPr>
@@ -4841,7 +4841,7 @@
           <p:cNvPr id="2" name="">
             <a:extLst xmlns:a="http://schemas.openxmlformats.org/drawingml/2006/main">
               <a:ext uri="{FF2B5EF4-FFF2-40B4-BE49-F238E27FC236}">
-                <a16:creationId xmlns:a16="http://schemas.microsoft.com/office/drawing/2014/main" id="{5E65096F-1569-46FE-A106-FBE7F31908A8}"/>
+                <a16:creationId xmlns:a16="http://schemas.microsoft.com/office/drawing/2014/main" id="{C97B13A7-0D03-4CD6-80D8-BD4E22E3B535}"/>
               </a:ext>
             </a:extLst>
           </p:cNvPr>
@@ -4899,7 +4899,7 @@
           <p:cNvPr id="3" name="">
             <a:extLst xmlns:a="http://schemas.openxmlformats.org/drawingml/2006/main">
               <a:ext uri="{FF2B5EF4-FFF2-40B4-BE49-F238E27FC236}">
-                <a16:creationId xmlns:a16="http://schemas.microsoft.com/office/drawing/2014/main" id="{354C1AA9-FA35-4E0E-A1D3-43C19430FB65}"/>
+                <a16:creationId xmlns:a16="http://schemas.microsoft.com/office/drawing/2014/main" id="{1E467D5F-8AFE-4596-8DE3-17084E949DF0}"/>
               </a:ext>
             </a:extLst>
           </p:cNvPr>
@@ -4957,7 +4957,7 @@
           <p:cNvPr id="4" name="">
             <a:extLst xmlns:a="http://schemas.openxmlformats.org/drawingml/2006/main">
               <a:ext uri="{FF2B5EF4-FFF2-40B4-BE49-F238E27FC236}">
-                <a16:creationId xmlns:a16="http://schemas.microsoft.com/office/drawing/2014/main" id="{1DA27F28-11E7-4D0C-9EDF-7D8CD846FD1A}"/>
+                <a16:creationId xmlns:a16="http://schemas.microsoft.com/office/drawing/2014/main" id="{DE30199A-310F-47E5-B7BE-C41B0BDCC8DF}"/>
               </a:ext>
             </a:extLst>
           </p:cNvPr>
@@ -5015,7 +5015,7 @@
           <p:cNvPr id="5" name="">
             <a:extLst xmlns:a="http://schemas.openxmlformats.org/drawingml/2006/main">
               <a:ext uri="{FF2B5EF4-FFF2-40B4-BE49-F238E27FC236}">
-                <a16:creationId xmlns:a16="http://schemas.microsoft.com/office/drawing/2014/main" id="{F96EF4E7-86E5-4603-954A-F798CF491E66}"/>
+                <a16:creationId xmlns:a16="http://schemas.microsoft.com/office/drawing/2014/main" id="{2957DD80-3CD6-41D7-8E06-58B2954279AE}"/>
               </a:ext>
             </a:extLst>
           </p:cNvPr>
@@ -5073,7 +5073,7 @@
           <p:cNvPr id="6" name="">
             <a:extLst xmlns:a="http://schemas.openxmlformats.org/drawingml/2006/main">
               <a:ext uri="{FF2B5EF4-FFF2-40B4-BE49-F238E27FC236}">
-                <a16:creationId xmlns:a16="http://schemas.microsoft.com/office/drawing/2014/main" id="{BB1C556F-90A6-4F07-BF97-08EC02DC64B3}"/>
+                <a16:creationId xmlns:a16="http://schemas.microsoft.com/office/drawing/2014/main" id="{DC0A1E9C-2765-444B-BD65-B80DD880D368}"/>
               </a:ext>
             </a:extLst>
           </p:cNvPr>
@@ -5131,7 +5131,7 @@
           <p:cNvPr id="7" name="">
             <a:extLst xmlns:a="http://schemas.openxmlformats.org/drawingml/2006/main">
               <a:ext uri="{FF2B5EF4-FFF2-40B4-BE49-F238E27FC236}">
-                <a16:creationId xmlns:a16="http://schemas.microsoft.com/office/drawing/2014/main" id="{8391C86F-931E-4409-8A48-B2E5381E6A09}"/>
+                <a16:creationId xmlns:a16="http://schemas.microsoft.com/office/drawing/2014/main" id="{C94671FF-7E60-4E06-9759-55F7DA45AB6C}"/>
               </a:ext>
             </a:extLst>
           </p:cNvPr>
@@ -5164,7 +5164,7 @@
           <p:cNvPr id="8" name="">
             <a:extLst xmlns:a="http://schemas.openxmlformats.org/drawingml/2006/main">
               <a:ext uri="{FF2B5EF4-FFF2-40B4-BE49-F238E27FC236}">
-                <a16:creationId xmlns:a16="http://schemas.microsoft.com/office/drawing/2014/main" id="{F216042D-CC0F-4836-830A-293F5E51F096}"/>
+                <a16:creationId xmlns:a16="http://schemas.microsoft.com/office/drawing/2014/main" id="{295AD3F0-7C09-4CDF-A359-DA519B589037}"/>
               </a:ext>
             </a:extLst>
           </p:cNvPr>
@@ -5222,7 +5222,7 @@
           <p:cNvPr id="9" name="">
             <a:extLst xmlns:a="http://schemas.openxmlformats.org/drawingml/2006/main">
               <a:ext uri="{FF2B5EF4-FFF2-40B4-BE49-F238E27FC236}">
-                <a16:creationId xmlns:a16="http://schemas.microsoft.com/office/drawing/2014/main" id="{F123E5BB-2C27-4B33-994B-86EC8DE91CC7}"/>
+                <a16:creationId xmlns:a16="http://schemas.microsoft.com/office/drawing/2014/main" id="{26C5E940-C677-4941-BCCF-B74B0DA9BB3C}"/>
               </a:ext>
             </a:extLst>
           </p:cNvPr>
@@ -5278,7 +5278,7 @@
     </p:spTree>
     <p:extLst>
       <p:ext uri="{BB962C8B-B14F-4D97-AF65-F5344CB8AC3E}">
-        <p14:creationId xmlns:p14="http://schemas.microsoft.com/office/powerpoint/2010/main" val="489161001"/>
+        <p14:creationId xmlns:p14="http://schemas.microsoft.com/office/powerpoint/2010/main" val="928709936"/>
       </p:ext>
     </p:extLst>
   </p:cSld>
@@ -5313,7 +5313,7 @@
           <p:nvPr/>
         </p:nvPicPr>
         <p:blipFill>
-          <a:blip xmlns:r="http://schemas.openxmlformats.org/officeDocument/2006/relationships" xmlns:a="http://schemas.openxmlformats.org/drawingml/2006/main" r:embed="R2ec90bd050ab4ff2"/>
+          <a:blip xmlns:r="http://schemas.openxmlformats.org/officeDocument/2006/relationships" xmlns:a="http://schemas.openxmlformats.org/drawingml/2006/main" r:embed="R09606ea69c5d475a"/>
           <a:stretch xmlns:a="http://schemas.openxmlformats.org/drawingml/2006/main"/>
         </p:blipFill>
         <p:spPr>
@@ -5331,7 +5331,7 @@
           <p:cNvPr id="2" name="">
             <a:extLst xmlns:a="http://schemas.openxmlformats.org/drawingml/2006/main">
               <a:ext uri="{FF2B5EF4-FFF2-40B4-BE49-F238E27FC236}">
-                <a16:creationId xmlns:a16="http://schemas.microsoft.com/office/drawing/2014/main" id="{F6A740CE-19B1-47E1-9CCE-287DD7DDA766}"/>
+                <a16:creationId xmlns:a16="http://schemas.microsoft.com/office/drawing/2014/main" id="{2E901992-7F69-4ACD-81B7-43D3B40E9B97}"/>
               </a:ext>
             </a:extLst>
           </p:cNvPr>
@@ -5389,7 +5389,7 @@
           <p:cNvPr id="3" name="">
             <a:extLst xmlns:a="http://schemas.openxmlformats.org/drawingml/2006/main">
               <a:ext uri="{FF2B5EF4-FFF2-40B4-BE49-F238E27FC236}">
-                <a16:creationId xmlns:a16="http://schemas.microsoft.com/office/drawing/2014/main" id="{71488FFF-4A2B-4EF6-8A2F-44686618A037}"/>
+                <a16:creationId xmlns:a16="http://schemas.microsoft.com/office/drawing/2014/main" id="{8CE48063-948F-4661-87F9-53B34DB93F65}"/>
               </a:ext>
             </a:extLst>
           </p:cNvPr>
@@ -5447,7 +5447,7 @@
           <p:cNvPr id="4" name="">
             <a:extLst xmlns:a="http://schemas.openxmlformats.org/drawingml/2006/main">
               <a:ext uri="{FF2B5EF4-FFF2-40B4-BE49-F238E27FC236}">
-                <a16:creationId xmlns:a16="http://schemas.microsoft.com/office/drawing/2014/main" id="{4E84CE9A-9BB9-41E7-BFC0-555FAF182215}"/>
+                <a16:creationId xmlns:a16="http://schemas.microsoft.com/office/drawing/2014/main" id="{00F67E9E-358A-47F7-A713-5CE42161EA8A}"/>
               </a:ext>
             </a:extLst>
           </p:cNvPr>
@@ -5505,7 +5505,7 @@
           <p:cNvPr id="5" name="">
             <a:extLst xmlns:a="http://schemas.openxmlformats.org/drawingml/2006/main">
               <a:ext uri="{FF2B5EF4-FFF2-40B4-BE49-F238E27FC236}">
-                <a16:creationId xmlns:a16="http://schemas.microsoft.com/office/drawing/2014/main" id="{0114850A-4B7C-464B-83B3-25EEC03469AD}"/>
+                <a16:creationId xmlns:a16="http://schemas.microsoft.com/office/drawing/2014/main" id="{D6CC0532-42AB-4ED0-9A31-040974A2D062}"/>
               </a:ext>
             </a:extLst>
           </p:cNvPr>
@@ -5563,7 +5563,7 @@
           <p:cNvPr id="6" name="">
             <a:extLst xmlns:a="http://schemas.openxmlformats.org/drawingml/2006/main">
               <a:ext uri="{FF2B5EF4-FFF2-40B4-BE49-F238E27FC236}">
-                <a16:creationId xmlns:a16="http://schemas.microsoft.com/office/drawing/2014/main" id="{1911706F-ACA1-4641-96CE-A878E40370A8}"/>
+                <a16:creationId xmlns:a16="http://schemas.microsoft.com/office/drawing/2014/main" id="{2AC13AD3-F688-4921-88CC-6D04A7C76198}"/>
               </a:ext>
             </a:extLst>
           </p:cNvPr>
@@ -5621,7 +5621,7 @@
           <p:cNvPr id="7" name="">
             <a:extLst xmlns:a="http://schemas.openxmlformats.org/drawingml/2006/main">
               <a:ext uri="{FF2B5EF4-FFF2-40B4-BE49-F238E27FC236}">
-                <a16:creationId xmlns:a16="http://schemas.microsoft.com/office/drawing/2014/main" id="{20100EEC-F1C0-422A-9485-47B42D54E2C8}"/>
+                <a16:creationId xmlns:a16="http://schemas.microsoft.com/office/drawing/2014/main" id="{A3ECBFA8-54F2-4FCB-82C0-9AB33A3BEBDC}"/>
               </a:ext>
             </a:extLst>
           </p:cNvPr>
@@ -5679,7 +5679,7 @@
           <p:cNvPr id="8" name="">
             <a:extLst xmlns:a="http://schemas.openxmlformats.org/drawingml/2006/main">
               <a:ext uri="{FF2B5EF4-FFF2-40B4-BE49-F238E27FC236}">
-                <a16:creationId xmlns:a16="http://schemas.microsoft.com/office/drawing/2014/main" id="{4F3A6368-8425-4433-B3F3-8E8A1A7C51BF}"/>
+                <a16:creationId xmlns:a16="http://schemas.microsoft.com/office/drawing/2014/main" id="{ACB3CA5E-A531-43D0-9840-BEA3D271C35E}"/>
               </a:ext>
             </a:extLst>
           </p:cNvPr>
@@ -5737,7 +5737,7 @@
           <p:cNvPr id="9" name="">
             <a:extLst xmlns:a="http://schemas.openxmlformats.org/drawingml/2006/main">
               <a:ext uri="{FF2B5EF4-FFF2-40B4-BE49-F238E27FC236}">
-                <a16:creationId xmlns:a16="http://schemas.microsoft.com/office/drawing/2014/main" id="{115C8D3C-1054-416B-A21D-63A5BEB47918}"/>
+                <a16:creationId xmlns:a16="http://schemas.microsoft.com/office/drawing/2014/main" id="{8CA315B2-D234-4CFB-AC78-50970F1C5942}"/>
               </a:ext>
             </a:extLst>
           </p:cNvPr>
@@ -5793,7 +5793,7 @@
     </p:spTree>
     <p:extLst>
       <p:ext uri="{BB962C8B-B14F-4D97-AF65-F5344CB8AC3E}">
-        <p14:creationId xmlns:p14="http://schemas.microsoft.com/office/powerpoint/2010/main" val="737087746"/>
+        <p14:creationId xmlns:p14="http://schemas.microsoft.com/office/powerpoint/2010/main" val="1492272952"/>
       </p:ext>
     </p:extLst>
   </p:cSld>
@@ -5828,7 +5828,7 @@
           <p:nvPr/>
         </p:nvPicPr>
         <p:blipFill>
-          <a:blip xmlns:r="http://schemas.openxmlformats.org/officeDocument/2006/relationships" xmlns:a="http://schemas.openxmlformats.org/drawingml/2006/main" r:embed="R9562f5c9af4a4763"/>
+          <a:blip xmlns:r="http://schemas.openxmlformats.org/officeDocument/2006/relationships" xmlns:a="http://schemas.openxmlformats.org/drawingml/2006/main" r:embed="Raed7980c949a4bdd"/>
           <a:stretch xmlns:a="http://schemas.openxmlformats.org/drawingml/2006/main"/>
         </p:blipFill>
         <p:spPr>
@@ -5846,7 +5846,7 @@
           <p:cNvPr id="2" name="">
             <a:extLst xmlns:a="http://schemas.openxmlformats.org/drawingml/2006/main">
               <a:ext uri="{FF2B5EF4-FFF2-40B4-BE49-F238E27FC236}">
-                <a16:creationId xmlns:a16="http://schemas.microsoft.com/office/drawing/2014/main" id="{0A138297-FA66-4810-B495-25E26199EA10}"/>
+                <a16:creationId xmlns:a16="http://schemas.microsoft.com/office/drawing/2014/main" id="{A953127B-1E5C-443E-9E5F-D9D94A9319EA}"/>
               </a:ext>
             </a:extLst>
           </p:cNvPr>
@@ -5904,7 +5904,7 @@
           <p:cNvPr id="3" name="">
             <a:extLst xmlns:a="http://schemas.openxmlformats.org/drawingml/2006/main">
               <a:ext uri="{FF2B5EF4-FFF2-40B4-BE49-F238E27FC236}">
-                <a16:creationId xmlns:a16="http://schemas.microsoft.com/office/drawing/2014/main" id="{ACA7ACDF-46A5-45DB-93C3-CB581C018DB3}"/>
+                <a16:creationId xmlns:a16="http://schemas.microsoft.com/office/drawing/2014/main" id="{9FA3B69E-4E58-4E57-B100-23C6902B797C}"/>
               </a:ext>
             </a:extLst>
           </p:cNvPr>
@@ -5962,7 +5962,7 @@
           <p:cNvPr id="4" name="">
             <a:extLst xmlns:a="http://schemas.openxmlformats.org/drawingml/2006/main">
               <a:ext uri="{FF2B5EF4-FFF2-40B4-BE49-F238E27FC236}">
-                <a16:creationId xmlns:a16="http://schemas.microsoft.com/office/drawing/2014/main" id="{77FD60FC-3D20-4AAF-9C0D-89DECDBEF26C}"/>
+                <a16:creationId xmlns:a16="http://schemas.microsoft.com/office/drawing/2014/main" id="{22F12F3E-4CEB-4029-8F70-DF48F4781751}"/>
               </a:ext>
             </a:extLst>
           </p:cNvPr>
@@ -6020,7 +6020,7 @@
           <p:cNvPr id="5" name="">
             <a:extLst xmlns:a="http://schemas.openxmlformats.org/drawingml/2006/main">
               <a:ext uri="{FF2B5EF4-FFF2-40B4-BE49-F238E27FC236}">
-                <a16:creationId xmlns:a16="http://schemas.microsoft.com/office/drawing/2014/main" id="{FC4C9F53-8407-4CF7-AE6C-65A22115BB3D}"/>
+                <a16:creationId xmlns:a16="http://schemas.microsoft.com/office/drawing/2014/main" id="{2C469837-8F5E-496B-A3F2-6600DB6046C3}"/>
               </a:ext>
             </a:extLst>
           </p:cNvPr>
@@ -6078,7 +6078,7 @@
           <p:cNvPr id="6" name="">
             <a:extLst xmlns:a="http://schemas.openxmlformats.org/drawingml/2006/main">
               <a:ext uri="{FF2B5EF4-FFF2-40B4-BE49-F238E27FC236}">
-                <a16:creationId xmlns:a16="http://schemas.microsoft.com/office/drawing/2014/main" id="{F8599E2E-18E4-4BE0-B308-039C3348CA35}"/>
+                <a16:creationId xmlns:a16="http://schemas.microsoft.com/office/drawing/2014/main" id="{7D8B01F5-7D1F-40FD-869F-B9ED44D48CA1}"/>
               </a:ext>
             </a:extLst>
           </p:cNvPr>
@@ -6136,7 +6136,7 @@
           <p:cNvPr id="7" name="">
             <a:extLst xmlns:a="http://schemas.openxmlformats.org/drawingml/2006/main">
               <a:ext uri="{FF2B5EF4-FFF2-40B4-BE49-F238E27FC236}">
-                <a16:creationId xmlns:a16="http://schemas.microsoft.com/office/drawing/2014/main" id="{F5ECDD53-84CF-45CE-8410-01DD2940F408}"/>
+                <a16:creationId xmlns:a16="http://schemas.microsoft.com/office/drawing/2014/main" id="{E06335E7-7198-42FF-A1CE-50DF98B23894}"/>
               </a:ext>
             </a:extLst>
           </p:cNvPr>
@@ -6194,7 +6194,7 @@
           <p:cNvPr id="8" name="">
             <a:extLst xmlns:a="http://schemas.openxmlformats.org/drawingml/2006/main">
               <a:ext uri="{FF2B5EF4-FFF2-40B4-BE49-F238E27FC236}">
-                <a16:creationId xmlns:a16="http://schemas.microsoft.com/office/drawing/2014/main" id="{834FE6EA-AF22-4D5C-8860-EAB18C4AF7DC}"/>
+                <a16:creationId xmlns:a16="http://schemas.microsoft.com/office/drawing/2014/main" id="{5C3C4B32-02D7-4DDB-983D-DABA6EB6627A}"/>
               </a:ext>
             </a:extLst>
           </p:cNvPr>
@@ -6252,7 +6252,7 @@
           <p:cNvPr id="9" name="">
             <a:extLst xmlns:a="http://schemas.openxmlformats.org/drawingml/2006/main">
               <a:ext uri="{FF2B5EF4-FFF2-40B4-BE49-F238E27FC236}">
-                <a16:creationId xmlns:a16="http://schemas.microsoft.com/office/drawing/2014/main" id="{A96EC06F-4CF5-49B8-B50E-8AD51322E394}"/>
+                <a16:creationId xmlns:a16="http://schemas.microsoft.com/office/drawing/2014/main" id="{0D2DCD9F-8C32-42B2-8D8F-B895F8E06A21}"/>
               </a:ext>
             </a:extLst>
           </p:cNvPr>
@@ -6285,7 +6285,7 @@
           <p:cNvPr id="10" name="">
             <a:extLst xmlns:a="http://schemas.openxmlformats.org/drawingml/2006/main">
               <a:ext uri="{FF2B5EF4-FFF2-40B4-BE49-F238E27FC236}">
-                <a16:creationId xmlns:a16="http://schemas.microsoft.com/office/drawing/2014/main" id="{03E0C4AC-D042-478F-833D-A1F10D55D857}"/>
+                <a16:creationId xmlns:a16="http://schemas.microsoft.com/office/drawing/2014/main" id="{9D626896-7032-401C-ADEF-50B692034800}"/>
               </a:ext>
             </a:extLst>
           </p:cNvPr>
@@ -6343,7 +6343,7 @@
           <p:cNvPr id="11" name="">
             <a:extLst xmlns:a="http://schemas.openxmlformats.org/drawingml/2006/main">
               <a:ext uri="{FF2B5EF4-FFF2-40B4-BE49-F238E27FC236}">
-                <a16:creationId xmlns:a16="http://schemas.microsoft.com/office/drawing/2014/main" id="{2EBC1389-1A92-461F-B9CC-F920A7AA91B1}"/>
+                <a16:creationId xmlns:a16="http://schemas.microsoft.com/office/drawing/2014/main" id="{B606D1D2-4EB2-4182-8C49-AC5319431050}"/>
               </a:ext>
             </a:extLst>
           </p:cNvPr>
@@ -6399,7 +6399,7 @@
     </p:spTree>
     <p:extLst>
       <p:ext uri="{BB962C8B-B14F-4D97-AF65-F5344CB8AC3E}">
-        <p14:creationId xmlns:p14="http://schemas.microsoft.com/office/powerpoint/2010/main" val="1378970825"/>
+        <p14:creationId xmlns:p14="http://schemas.microsoft.com/office/powerpoint/2010/main" val="1170265428"/>
       </p:ext>
     </p:extLst>
   </p:cSld>
@@ -6434,7 +6434,7 @@
           <p:nvPr/>
         </p:nvPicPr>
         <p:blipFill>
-          <a:blip xmlns:r="http://schemas.openxmlformats.org/officeDocument/2006/relationships" xmlns:a="http://schemas.openxmlformats.org/drawingml/2006/main" r:embed="R00e8dafb3c7f479b"/>
+          <a:blip xmlns:r="http://schemas.openxmlformats.org/officeDocument/2006/relationships" xmlns:a="http://schemas.openxmlformats.org/drawingml/2006/main" r:embed="Rf97ad624dd504912"/>
           <a:stretch xmlns:a="http://schemas.openxmlformats.org/drawingml/2006/main"/>
         </p:blipFill>
         <p:spPr>
@@ -6452,7 +6452,7 @@
           <p:cNvPr id="2" name="">
             <a:extLst xmlns:a="http://schemas.openxmlformats.org/drawingml/2006/main">
               <a:ext uri="{FF2B5EF4-FFF2-40B4-BE49-F238E27FC236}">
-                <a16:creationId xmlns:a16="http://schemas.microsoft.com/office/drawing/2014/main" id="{0A63E5E1-DA56-4F83-9029-57046078F7D7}"/>
+                <a16:creationId xmlns:a16="http://schemas.microsoft.com/office/drawing/2014/main" id="{16671647-2B06-427F-93C3-0446A7311691}"/>
               </a:ext>
             </a:extLst>
           </p:cNvPr>
@@ -6508,7 +6508,7 @@
     </p:spTree>
     <p:extLst>
       <p:ext uri="{BB962C8B-B14F-4D97-AF65-F5344CB8AC3E}">
-        <p14:creationId xmlns:p14="http://schemas.microsoft.com/office/powerpoint/2010/main" val="926295453"/>
+        <p14:creationId xmlns:p14="http://schemas.microsoft.com/office/powerpoint/2010/main" val="1695888879"/>
       </p:ext>
     </p:extLst>
   </p:cSld>
@@ -6539,7 +6539,7 @@
           <p:cNvPr id="31" name="">
             <a:extLst xmlns:a="http://schemas.openxmlformats.org/drawingml/2006/main">
               <a:ext uri="{FF2B5EF4-FFF2-40B4-BE49-F238E27FC236}">
-                <a16:creationId xmlns:a16="http://schemas.microsoft.com/office/drawing/2014/main" id="{8E76C4AF-CCD1-43D9-A1AB-0CDD4B092E30}"/>
+                <a16:creationId xmlns:a16="http://schemas.microsoft.com/office/drawing/2014/main" id="{D74E2949-6C69-4B45-BDDC-BB4C6526AB65}"/>
               </a:ext>
             </a:extLst>
           </p:cNvPr>
@@ -6597,7 +6597,7 @@
           <p:cNvPr id="2" name="">
             <a:extLst xmlns:a="http://schemas.openxmlformats.org/drawingml/2006/main">
               <a:ext uri="{FF2B5EF4-FFF2-40B4-BE49-F238E27FC236}">
-                <a16:creationId xmlns:a16="http://schemas.microsoft.com/office/drawing/2014/main" id="{E7EE26B4-AA58-42CD-B50C-B775B5E401B5}"/>
+                <a16:creationId xmlns:a16="http://schemas.microsoft.com/office/drawing/2014/main" id="{7210841B-22C7-4BFD-A39C-CCE4624ABA3E}"/>
               </a:ext>
             </a:extLst>
           </p:cNvPr>
@@ -6655,7 +6655,7 @@
           <p:cNvPr id="3" name="">
             <a:extLst xmlns:a="http://schemas.openxmlformats.org/drawingml/2006/main">
               <a:ext uri="{FF2B5EF4-FFF2-40B4-BE49-F238E27FC236}">
-                <a16:creationId xmlns:a16="http://schemas.microsoft.com/office/drawing/2014/main" id="{3450335B-7A62-4246-9135-A3C7B512AE99}"/>
+                <a16:creationId xmlns:a16="http://schemas.microsoft.com/office/drawing/2014/main" id="{AFE01B33-552C-4DFC-AD19-32D0A5490BA3}"/>
               </a:ext>
             </a:extLst>
           </p:cNvPr>
@@ -6713,7 +6713,7 @@
           <p:cNvPr id="4" name="">
             <a:extLst xmlns:a="http://schemas.openxmlformats.org/drawingml/2006/main">
               <a:ext uri="{FF2B5EF4-FFF2-40B4-BE49-F238E27FC236}">
-                <a16:creationId xmlns:a16="http://schemas.microsoft.com/office/drawing/2014/main" id="{76325C10-213F-4661-A6F5-66F111064EDC}"/>
+                <a16:creationId xmlns:a16="http://schemas.microsoft.com/office/drawing/2014/main" id="{FD297528-F883-4479-A06F-27F81BDF7B23}"/>
               </a:ext>
             </a:extLst>
           </p:cNvPr>
@@ -6746,7 +6746,7 @@
           <p:cNvPr id="5" name="">
             <a:extLst xmlns:a="http://schemas.openxmlformats.org/drawingml/2006/main">
               <a:ext uri="{FF2B5EF4-FFF2-40B4-BE49-F238E27FC236}">
-                <a16:creationId xmlns:a16="http://schemas.microsoft.com/office/drawing/2014/main" id="{7872A65A-513C-47D3-A814-0AA6149CFA51}"/>
+                <a16:creationId xmlns:a16="http://schemas.microsoft.com/office/drawing/2014/main" id="{68A47D6F-0599-4024-A6E3-5C138C0F64E0}"/>
               </a:ext>
             </a:extLst>
           </p:cNvPr>
@@ -6804,7 +6804,7 @@
           <p:cNvPr id="6" name="">
             <a:extLst xmlns:a="http://schemas.openxmlformats.org/drawingml/2006/main">
               <a:ext uri="{FF2B5EF4-FFF2-40B4-BE49-F238E27FC236}">
-                <a16:creationId xmlns:a16="http://schemas.microsoft.com/office/drawing/2014/main" id="{C42386C1-BF1C-47CE-B76A-A0E2E3022359}"/>
+                <a16:creationId xmlns:a16="http://schemas.microsoft.com/office/drawing/2014/main" id="{C02B1E53-C657-460B-BBCB-8B15E9925B56}"/>
               </a:ext>
             </a:extLst>
           </p:cNvPr>
@@ -6837,7 +6837,7 @@
           <p:cNvPr id="7" name="">
             <a:extLst xmlns:a="http://schemas.openxmlformats.org/drawingml/2006/main">
               <a:ext uri="{FF2B5EF4-FFF2-40B4-BE49-F238E27FC236}">
-                <a16:creationId xmlns:a16="http://schemas.microsoft.com/office/drawing/2014/main" id="{88FA1834-05D5-4FEE-8CBE-03823895C60C}"/>
+                <a16:creationId xmlns:a16="http://schemas.microsoft.com/office/drawing/2014/main" id="{05FFC683-003B-46DA-BAC6-D956C9B5CCBF}"/>
               </a:ext>
             </a:extLst>
           </p:cNvPr>
@@ -6895,7 +6895,7 @@
           <p:cNvPr id="8" name="">
             <a:extLst xmlns:a="http://schemas.openxmlformats.org/drawingml/2006/main">
               <a:ext uri="{FF2B5EF4-FFF2-40B4-BE49-F238E27FC236}">
-                <a16:creationId xmlns:a16="http://schemas.microsoft.com/office/drawing/2014/main" id="{6D96B42E-43B6-4843-AB0B-5F846D5D9CD7}"/>
+                <a16:creationId xmlns:a16="http://schemas.microsoft.com/office/drawing/2014/main" id="{8E6BE9FE-8675-4890-82BE-05E58F4A2132}"/>
               </a:ext>
             </a:extLst>
           </p:cNvPr>
@@ -6928,7 +6928,7 @@
           <p:cNvPr id="9" name="">
             <a:extLst xmlns:a="http://schemas.openxmlformats.org/drawingml/2006/main">
               <a:ext uri="{FF2B5EF4-FFF2-40B4-BE49-F238E27FC236}">
-                <a16:creationId xmlns:a16="http://schemas.microsoft.com/office/drawing/2014/main" id="{1CC33F51-F58D-4E2D-9BB3-005B7C45F96F}"/>
+                <a16:creationId xmlns:a16="http://schemas.microsoft.com/office/drawing/2014/main" id="{F2786F69-3559-420C-B912-7123113EBA53}"/>
               </a:ext>
             </a:extLst>
           </p:cNvPr>
@@ -6986,7 +6986,7 @@
           <p:cNvPr id="10" name="">
             <a:extLst xmlns:a="http://schemas.openxmlformats.org/drawingml/2006/main">
               <a:ext uri="{FF2B5EF4-FFF2-40B4-BE49-F238E27FC236}">
-                <a16:creationId xmlns:a16="http://schemas.microsoft.com/office/drawing/2014/main" id="{3E4713EE-8B32-4F27-BE1E-86E3963FEAE4}"/>
+                <a16:creationId xmlns:a16="http://schemas.microsoft.com/office/drawing/2014/main" id="{30342684-4EA8-4296-9391-5DA9E6F6D596}"/>
               </a:ext>
             </a:extLst>
           </p:cNvPr>
@@ -7019,7 +7019,7 @@
           <p:cNvPr id="11" name="">
             <a:extLst xmlns:a="http://schemas.openxmlformats.org/drawingml/2006/main">
               <a:ext uri="{FF2B5EF4-FFF2-40B4-BE49-F238E27FC236}">
-                <a16:creationId xmlns:a16="http://schemas.microsoft.com/office/drawing/2014/main" id="{1B7732BE-6E4B-43C8-9449-3919D67C15F5}"/>
+                <a16:creationId xmlns:a16="http://schemas.microsoft.com/office/drawing/2014/main" id="{FB3223EC-0948-49B5-AAAE-DDC31BAE1D27}"/>
               </a:ext>
             </a:extLst>
           </p:cNvPr>
@@ -7077,7 +7077,7 @@
           <p:cNvPr id="12" name="">
             <a:extLst xmlns:a="http://schemas.openxmlformats.org/drawingml/2006/main">
               <a:ext uri="{FF2B5EF4-FFF2-40B4-BE49-F238E27FC236}">
-                <a16:creationId xmlns:a16="http://schemas.microsoft.com/office/drawing/2014/main" id="{E7606678-F512-4ED5-B118-B8990BE72016}"/>
+                <a16:creationId xmlns:a16="http://schemas.microsoft.com/office/drawing/2014/main" id="{2B9AF527-BCCF-466B-9721-E5EC56347EA1}"/>
               </a:ext>
             </a:extLst>
           </p:cNvPr>
@@ -7110,7 +7110,7 @@
           <p:cNvPr id="13" name="">
             <a:extLst xmlns:a="http://schemas.openxmlformats.org/drawingml/2006/main">
               <a:ext uri="{FF2B5EF4-FFF2-40B4-BE49-F238E27FC236}">
-                <a16:creationId xmlns:a16="http://schemas.microsoft.com/office/drawing/2014/main" id="{72EEEDC5-2A2C-49AE-83A6-F9AF03B8F241}"/>
+                <a16:creationId xmlns:a16="http://schemas.microsoft.com/office/drawing/2014/main" id="{6A527BBB-FA59-48AF-BA36-3A2947F8EE15}"/>
               </a:ext>
             </a:extLst>
           </p:cNvPr>
@@ -7168,7 +7168,7 @@
           <p:cNvPr id="14" name="">
             <a:extLst xmlns:a="http://schemas.openxmlformats.org/drawingml/2006/main">
               <a:ext uri="{FF2B5EF4-FFF2-40B4-BE49-F238E27FC236}">
-                <a16:creationId xmlns:a16="http://schemas.microsoft.com/office/drawing/2014/main" id="{5EACB8EE-0D3B-40F3-9EF7-C458F8D8A477}"/>
+                <a16:creationId xmlns:a16="http://schemas.microsoft.com/office/drawing/2014/main" id="{F15DCA58-7E6F-4422-A27F-876E9FF91A88}"/>
               </a:ext>
             </a:extLst>
           </p:cNvPr>
@@ -7226,7 +7226,7 @@
           <p:cNvPr id="15" name="">
             <a:extLst xmlns:a="http://schemas.openxmlformats.org/drawingml/2006/main">
               <a:ext uri="{FF2B5EF4-FFF2-40B4-BE49-F238E27FC236}">
-                <a16:creationId xmlns:a16="http://schemas.microsoft.com/office/drawing/2014/main" id="{34E75319-4022-4A68-9B7E-CE6C319F2661}"/>
+                <a16:creationId xmlns:a16="http://schemas.microsoft.com/office/drawing/2014/main" id="{15E341B2-5275-430C-A424-3ABEDE3F1C90}"/>
               </a:ext>
             </a:extLst>
           </p:cNvPr>
@@ -7259,7 +7259,7 @@
           <p:cNvPr id="16" name="">
             <a:extLst xmlns:a="http://schemas.openxmlformats.org/drawingml/2006/main">
               <a:ext uri="{FF2B5EF4-FFF2-40B4-BE49-F238E27FC236}">
-                <a16:creationId xmlns:a16="http://schemas.microsoft.com/office/drawing/2014/main" id="{0E024B0C-B7E4-4FE6-9410-CA600695CB68}"/>
+                <a16:creationId xmlns:a16="http://schemas.microsoft.com/office/drawing/2014/main" id="{E736B43C-E040-44D0-8933-3E60839B69B5}"/>
               </a:ext>
             </a:extLst>
           </p:cNvPr>
@@ -7317,7 +7317,7 @@
           <p:cNvPr id="17" name="">
             <a:extLst xmlns:a="http://schemas.openxmlformats.org/drawingml/2006/main">
               <a:ext uri="{FF2B5EF4-FFF2-40B4-BE49-F238E27FC236}">
-                <a16:creationId xmlns:a16="http://schemas.microsoft.com/office/drawing/2014/main" id="{2D73D052-6C46-48A5-8265-84D4F7872937}"/>
+                <a16:creationId xmlns:a16="http://schemas.microsoft.com/office/drawing/2014/main" id="{F9B61217-AF67-4F39-A239-B8326DFC0B63}"/>
               </a:ext>
             </a:extLst>
           </p:cNvPr>
@@ -7375,7 +7375,7 @@
           <p:cNvPr id="18" name="">
             <a:extLst xmlns:a="http://schemas.openxmlformats.org/drawingml/2006/main">
               <a:ext uri="{FF2B5EF4-FFF2-40B4-BE49-F238E27FC236}">
-                <a16:creationId xmlns:a16="http://schemas.microsoft.com/office/drawing/2014/main" id="{3E7BA3E3-09C5-46B4-9B43-2C45F56AC7EA}"/>
+                <a16:creationId xmlns:a16="http://schemas.microsoft.com/office/drawing/2014/main" id="{6B1AC273-D8E4-4F28-A437-A72965E7379C}"/>
               </a:ext>
             </a:extLst>
           </p:cNvPr>
@@ -7433,7 +7433,7 @@
           <p:cNvPr id="19" name="">
             <a:extLst xmlns:a="http://schemas.openxmlformats.org/drawingml/2006/main">
               <a:ext uri="{FF2B5EF4-FFF2-40B4-BE49-F238E27FC236}">
-                <a16:creationId xmlns:a16="http://schemas.microsoft.com/office/drawing/2014/main" id="{DAE33899-674B-48BC-820A-32063B4817D1}"/>
+                <a16:creationId xmlns:a16="http://schemas.microsoft.com/office/drawing/2014/main" id="{F79B1E76-5677-4211-8B47-0C3CF71B9DBF}"/>
               </a:ext>
             </a:extLst>
           </p:cNvPr>
@@ -7491,7 +7491,7 @@
           <p:cNvPr id="20" name="">
             <a:extLst xmlns:a="http://schemas.openxmlformats.org/drawingml/2006/main">
               <a:ext uri="{FF2B5EF4-FFF2-40B4-BE49-F238E27FC236}">
-                <a16:creationId xmlns:a16="http://schemas.microsoft.com/office/drawing/2014/main" id="{5431E013-71D1-4693-AEB8-49E65B3EA6E7}"/>
+                <a16:creationId xmlns:a16="http://schemas.microsoft.com/office/drawing/2014/main" id="{2D8068CC-4E10-45CC-A10A-B7F68F0A577D}"/>
               </a:ext>
             </a:extLst>
           </p:cNvPr>
@@ -7524,7 +7524,7 @@
           <p:cNvPr id="21" name="">
             <a:extLst xmlns:a="http://schemas.openxmlformats.org/drawingml/2006/main">
               <a:ext uri="{FF2B5EF4-FFF2-40B4-BE49-F238E27FC236}">
-                <a16:creationId xmlns:a16="http://schemas.microsoft.com/office/drawing/2014/main" id="{088CF720-915E-41CB-8988-98267EEE8D7A}"/>
+                <a16:creationId xmlns:a16="http://schemas.microsoft.com/office/drawing/2014/main" id="{CB377946-7813-48FB-899E-E71437FA09D3}"/>
               </a:ext>
             </a:extLst>
           </p:cNvPr>
@@ -7582,7 +7582,7 @@
           <p:cNvPr id="22" name="">
             <a:extLst xmlns:a="http://schemas.openxmlformats.org/drawingml/2006/main">
               <a:ext uri="{FF2B5EF4-FFF2-40B4-BE49-F238E27FC236}">
-                <a16:creationId xmlns:a16="http://schemas.microsoft.com/office/drawing/2014/main" id="{2E25C60A-D7F8-4041-9E4C-470ECA81DB9F}"/>
+                <a16:creationId xmlns:a16="http://schemas.microsoft.com/office/drawing/2014/main" id="{1B24381E-85C6-4670-9945-EF1E196AF3F3}"/>
               </a:ext>
             </a:extLst>
           </p:cNvPr>
@@ -7640,7 +7640,7 @@
           <p:cNvPr id="23" name="">
             <a:extLst xmlns:a="http://schemas.openxmlformats.org/drawingml/2006/main">
               <a:ext uri="{FF2B5EF4-FFF2-40B4-BE49-F238E27FC236}">
-                <a16:creationId xmlns:a16="http://schemas.microsoft.com/office/drawing/2014/main" id="{02968E47-FB10-47FA-B09F-F7C3C953E039}"/>
+                <a16:creationId xmlns:a16="http://schemas.microsoft.com/office/drawing/2014/main" id="{CC488579-0945-4066-8A2A-A1823C3A5488}"/>
               </a:ext>
             </a:extLst>
           </p:cNvPr>
@@ -7698,7 +7698,7 @@
           <p:cNvPr id="24" name="">
             <a:extLst xmlns:a="http://schemas.openxmlformats.org/drawingml/2006/main">
               <a:ext uri="{FF2B5EF4-FFF2-40B4-BE49-F238E27FC236}">
-                <a16:creationId xmlns:a16="http://schemas.microsoft.com/office/drawing/2014/main" id="{94707CB2-D57A-4598-B528-D956C3B594F1}"/>
+                <a16:creationId xmlns:a16="http://schemas.microsoft.com/office/drawing/2014/main" id="{B364DAC6-C0C6-48F0-AE95-8C463E890322}"/>
               </a:ext>
             </a:extLst>
           </p:cNvPr>
@@ -7756,7 +7756,7 @@
           <p:cNvPr id="25" name="">
             <a:extLst xmlns:a="http://schemas.openxmlformats.org/drawingml/2006/main">
               <a:ext uri="{FF2B5EF4-FFF2-40B4-BE49-F238E27FC236}">
-                <a16:creationId xmlns:a16="http://schemas.microsoft.com/office/drawing/2014/main" id="{CAA83E3D-929B-4FB3-B2F4-FB10363514D8}"/>
+                <a16:creationId xmlns:a16="http://schemas.microsoft.com/office/drawing/2014/main" id="{EF686F1D-E459-45AF-92C3-7033DB3E0E39}"/>
               </a:ext>
             </a:extLst>
           </p:cNvPr>
@@ -7814,7 +7814,7 @@
           <p:cNvPr id="26" name="">
             <a:extLst xmlns:a="http://schemas.openxmlformats.org/drawingml/2006/main">
               <a:ext uri="{FF2B5EF4-FFF2-40B4-BE49-F238E27FC236}">
-                <a16:creationId xmlns:a16="http://schemas.microsoft.com/office/drawing/2014/main" id="{3DFAE572-2585-4C91-94B6-CEBA421A67BD}"/>
+                <a16:creationId xmlns:a16="http://schemas.microsoft.com/office/drawing/2014/main" id="{E036DC6A-E479-4A88-B9F8-393EE3716F83}"/>
               </a:ext>
             </a:extLst>
           </p:cNvPr>
@@ -7872,7 +7872,7 @@
           <p:cNvPr id="27" name="">
             <a:extLst xmlns:a="http://schemas.openxmlformats.org/drawingml/2006/main">
               <a:ext uri="{FF2B5EF4-FFF2-40B4-BE49-F238E27FC236}">
-                <a16:creationId xmlns:a16="http://schemas.microsoft.com/office/drawing/2014/main" id="{4DF49093-262F-4BB2-808E-1FD0721F3E97}"/>
+                <a16:creationId xmlns:a16="http://schemas.microsoft.com/office/drawing/2014/main" id="{2F6C5E8B-43CE-41E4-B299-9C1709A024D1}"/>
               </a:ext>
             </a:extLst>
           </p:cNvPr>
@@ -7930,7 +7930,7 @@
           <p:cNvPr id="28" name="">
             <a:extLst xmlns:a="http://schemas.openxmlformats.org/drawingml/2006/main">
               <a:ext uri="{FF2B5EF4-FFF2-40B4-BE49-F238E27FC236}">
-                <a16:creationId xmlns:a16="http://schemas.microsoft.com/office/drawing/2014/main" id="{190A3FA3-D2F1-4ED9-8DDF-91FC7BCB62F2}"/>
+                <a16:creationId xmlns:a16="http://schemas.microsoft.com/office/drawing/2014/main" id="{8BD74125-7276-4C9E-B80B-FA33C0789239}"/>
               </a:ext>
             </a:extLst>
           </p:cNvPr>
@@ -7988,7 +7988,7 @@
           <p:cNvPr id="29" name="">
             <a:extLst xmlns:a="http://schemas.openxmlformats.org/drawingml/2006/main">
               <a:ext uri="{FF2B5EF4-FFF2-40B4-BE49-F238E27FC236}">
-                <a16:creationId xmlns:a16="http://schemas.microsoft.com/office/drawing/2014/main" id="{D0A0AA5A-75F5-4460-9FC0-4C1922383E1C}"/>
+                <a16:creationId xmlns:a16="http://schemas.microsoft.com/office/drawing/2014/main" id="{969A825E-0364-42B9-909E-434556279FFA}"/>
               </a:ext>
             </a:extLst>
           </p:cNvPr>
@@ -8021,7 +8021,7 @@
           <p:cNvPr id="30" name="">
             <a:extLst xmlns:a="http://schemas.openxmlformats.org/drawingml/2006/main">
               <a:ext uri="{FF2B5EF4-FFF2-40B4-BE49-F238E27FC236}">
-                <a16:creationId xmlns:a16="http://schemas.microsoft.com/office/drawing/2014/main" id="{35210472-0ECC-4809-BFCD-9C30C0B75B67}"/>
+                <a16:creationId xmlns:a16="http://schemas.microsoft.com/office/drawing/2014/main" id="{A02740F6-D03A-46EA-AE91-A341C8411205}"/>
               </a:ext>
             </a:extLst>
           </p:cNvPr>
@@ -8077,7 +8077,7 @@
     </p:spTree>
     <p:extLst>
       <p:ext uri="{BB962C8B-B14F-4D97-AF65-F5344CB8AC3E}">
-        <p14:creationId xmlns:p14="http://schemas.microsoft.com/office/powerpoint/2010/main" val="182487775"/>
+        <p14:creationId xmlns:p14="http://schemas.microsoft.com/office/powerpoint/2010/main" val="891646507"/>
       </p:ext>
     </p:extLst>
   </p:cSld>
@@ -8112,7 +8112,7 @@
           <p:nvPr/>
         </p:nvPicPr>
         <p:blipFill>
-          <a:blip xmlns:r="http://schemas.openxmlformats.org/officeDocument/2006/relationships" xmlns:a="http://schemas.openxmlformats.org/drawingml/2006/main" r:embed="Rc2aa103b38c4422c"/>
+          <a:blip xmlns:r="http://schemas.openxmlformats.org/officeDocument/2006/relationships" xmlns:a="http://schemas.openxmlformats.org/drawingml/2006/main" r:embed="Ree85e9d02eaf4624"/>
           <a:stretch xmlns:a="http://schemas.openxmlformats.org/drawingml/2006/main"/>
         </p:blipFill>
         <p:spPr>
@@ -8130,7 +8130,7 @@
           <p:cNvPr id="2" name="">
             <a:extLst xmlns:a="http://schemas.openxmlformats.org/drawingml/2006/main">
               <a:ext uri="{FF2B5EF4-FFF2-40B4-BE49-F238E27FC236}">
-                <a16:creationId xmlns:a16="http://schemas.microsoft.com/office/drawing/2014/main" id="{CC6FCF89-E2B9-4A57-B6FB-FD66E8935BC1}"/>
+                <a16:creationId xmlns:a16="http://schemas.microsoft.com/office/drawing/2014/main" id="{8FD0D7C9-04BD-4C53-A06B-C3F83D4099A5}"/>
               </a:ext>
             </a:extLst>
           </p:cNvPr>
@@ -8186,7 +8186,7 @@
     </p:spTree>
     <p:extLst>
       <p:ext uri="{BB962C8B-B14F-4D97-AF65-F5344CB8AC3E}">
-        <p14:creationId xmlns:p14="http://schemas.microsoft.com/office/powerpoint/2010/main" val="1847402406"/>
+        <p14:creationId xmlns:p14="http://schemas.microsoft.com/office/powerpoint/2010/main" val="994351574"/>
       </p:ext>
     </p:extLst>
   </p:cSld>
@@ -8217,7 +8217,7 @@
           <p:cNvPr id="20" name="">
             <a:extLst xmlns:a="http://schemas.openxmlformats.org/drawingml/2006/main">
               <a:ext uri="{FF2B5EF4-FFF2-40B4-BE49-F238E27FC236}">
-                <a16:creationId xmlns:a16="http://schemas.microsoft.com/office/drawing/2014/main" id="{03E15C26-3A99-495F-A6A0-E43F2DA8BF89}"/>
+                <a16:creationId xmlns:a16="http://schemas.microsoft.com/office/drawing/2014/main" id="{767C4B7A-FE93-43DB-9810-02D490555F02}"/>
               </a:ext>
             </a:extLst>
           </p:cNvPr>
@@ -8275,7 +8275,7 @@
           <p:cNvPr id="2" name="">
             <a:extLst xmlns:a="http://schemas.openxmlformats.org/drawingml/2006/main">
               <a:ext uri="{FF2B5EF4-FFF2-40B4-BE49-F238E27FC236}">
-                <a16:creationId xmlns:a16="http://schemas.microsoft.com/office/drawing/2014/main" id="{C61215B6-ADE2-4234-9FA4-F6F1FE3CD7DA}"/>
+                <a16:creationId xmlns:a16="http://schemas.microsoft.com/office/drawing/2014/main" id="{8723875F-7EF0-44BC-AEFF-321E8C193070}"/>
               </a:ext>
             </a:extLst>
           </p:cNvPr>
@@ -8333,7 +8333,7 @@
           <p:cNvPr id="3" name="">
             <a:extLst xmlns:a="http://schemas.openxmlformats.org/drawingml/2006/main">
               <a:ext uri="{FF2B5EF4-FFF2-40B4-BE49-F238E27FC236}">
-                <a16:creationId xmlns:a16="http://schemas.microsoft.com/office/drawing/2014/main" id="{E81A7572-D406-46AC-980B-996AF6420CBC}"/>
+                <a16:creationId xmlns:a16="http://schemas.microsoft.com/office/drawing/2014/main" id="{A37CF1A0-C6A1-4442-993B-89FAD0EDCA79}"/>
               </a:ext>
             </a:extLst>
           </p:cNvPr>
@@ -8391,7 +8391,7 @@
           <p:cNvPr id="4" name="">
             <a:extLst xmlns:a="http://schemas.openxmlformats.org/drawingml/2006/main">
               <a:ext uri="{FF2B5EF4-FFF2-40B4-BE49-F238E27FC236}">
-                <a16:creationId xmlns:a16="http://schemas.microsoft.com/office/drawing/2014/main" id="{651C08BE-BDE6-4957-9EEE-08E5621FC0DB}"/>
+                <a16:creationId xmlns:a16="http://schemas.microsoft.com/office/drawing/2014/main" id="{F300A189-A6DB-4A50-8EDC-2445F7FB25B8}"/>
               </a:ext>
             </a:extLst>
           </p:cNvPr>
@@ -8424,7 +8424,7 @@
           <p:cNvPr id="5" name="">
             <a:extLst xmlns:a="http://schemas.openxmlformats.org/drawingml/2006/main">
               <a:ext uri="{FF2B5EF4-FFF2-40B4-BE49-F238E27FC236}">
-                <a16:creationId xmlns:a16="http://schemas.microsoft.com/office/drawing/2014/main" id="{41DCC78E-C650-464B-BF1F-8083F62330D2}"/>
+                <a16:creationId xmlns:a16="http://schemas.microsoft.com/office/drawing/2014/main" id="{4F2E7B16-AF9D-45B7-BA61-2EAAAD8A2E14}"/>
               </a:ext>
             </a:extLst>
           </p:cNvPr>
@@ -8482,7 +8482,7 @@
           <p:cNvPr id="6" name="">
             <a:extLst xmlns:a="http://schemas.openxmlformats.org/drawingml/2006/main">
               <a:ext uri="{FF2B5EF4-FFF2-40B4-BE49-F238E27FC236}">
-                <a16:creationId xmlns:a16="http://schemas.microsoft.com/office/drawing/2014/main" id="{00A11A10-1384-491F-9516-EC05E87EF7EF}"/>
+                <a16:creationId xmlns:a16="http://schemas.microsoft.com/office/drawing/2014/main" id="{BF3DAF7A-2E18-41FC-B404-EB8A57EF1064}"/>
               </a:ext>
             </a:extLst>
           </p:cNvPr>
@@ -8540,7 +8540,7 @@
           <p:cNvPr id="7" name="">
             <a:extLst xmlns:a="http://schemas.openxmlformats.org/drawingml/2006/main">
               <a:ext uri="{FF2B5EF4-FFF2-40B4-BE49-F238E27FC236}">
-                <a16:creationId xmlns:a16="http://schemas.microsoft.com/office/drawing/2014/main" id="{BAC6842B-B507-48CE-A4F6-64CA2911EFC8}"/>
+                <a16:creationId xmlns:a16="http://schemas.microsoft.com/office/drawing/2014/main" id="{AE0B15D1-3E8E-4306-9565-8B9DEDE5D94D}"/>
               </a:ext>
             </a:extLst>
           </p:cNvPr>
@@ -8598,7 +8598,7 @@
           <p:cNvPr id="8" name="">
             <a:extLst xmlns:a="http://schemas.openxmlformats.org/drawingml/2006/main">
               <a:ext uri="{FF2B5EF4-FFF2-40B4-BE49-F238E27FC236}">
-                <a16:creationId xmlns:a16="http://schemas.microsoft.com/office/drawing/2014/main" id="{14FF30C5-6789-4D77-AA6C-E631D3332865}"/>
+                <a16:creationId xmlns:a16="http://schemas.microsoft.com/office/drawing/2014/main" id="{16C791E1-32DE-486A-BB3E-3C04F9E38C50}"/>
               </a:ext>
             </a:extLst>
           </p:cNvPr>
@@ -8656,7 +8656,7 @@
           <p:cNvPr id="9" name="">
             <a:extLst xmlns:a="http://schemas.openxmlformats.org/drawingml/2006/main">
               <a:ext uri="{FF2B5EF4-FFF2-40B4-BE49-F238E27FC236}">
-                <a16:creationId xmlns:a16="http://schemas.microsoft.com/office/drawing/2014/main" id="{314E809A-4814-4882-8ED1-349B4DF3FD3C}"/>
+                <a16:creationId xmlns:a16="http://schemas.microsoft.com/office/drawing/2014/main" id="{8F98A148-B7D7-45B5-8D8A-89ACC4DE4EE8}"/>
               </a:ext>
             </a:extLst>
           </p:cNvPr>
@@ -8714,7 +8714,7 @@
           <p:cNvPr id="10" name="">
             <a:extLst xmlns:a="http://schemas.openxmlformats.org/drawingml/2006/main">
               <a:ext uri="{FF2B5EF4-FFF2-40B4-BE49-F238E27FC236}">
-                <a16:creationId xmlns:a16="http://schemas.microsoft.com/office/drawing/2014/main" id="{49F240AA-7667-4F7F-9CB0-30E5ED19602B}"/>
+                <a16:creationId xmlns:a16="http://schemas.microsoft.com/office/drawing/2014/main" id="{F658D13C-6200-4B9A-8B9A-47488FE77B3B}"/>
               </a:ext>
             </a:extLst>
           </p:cNvPr>
@@ -8772,7 +8772,7 @@
           <p:cNvPr id="11" name="">
             <a:extLst xmlns:a="http://schemas.openxmlformats.org/drawingml/2006/main">
               <a:ext uri="{FF2B5EF4-FFF2-40B4-BE49-F238E27FC236}">
-                <a16:creationId xmlns:a16="http://schemas.microsoft.com/office/drawing/2014/main" id="{F54892FE-1E5C-42E1-9602-A3D9D72720AD}"/>
+                <a16:creationId xmlns:a16="http://schemas.microsoft.com/office/drawing/2014/main" id="{3D5FDFDB-A221-488F-99AF-76BC2AC347DD}"/>
               </a:ext>
             </a:extLst>
           </p:cNvPr>
@@ -8805,7 +8805,7 @@
           <p:cNvPr id="12" name="">
             <a:extLst xmlns:a="http://schemas.openxmlformats.org/drawingml/2006/main">
               <a:ext uri="{FF2B5EF4-FFF2-40B4-BE49-F238E27FC236}">
-                <a16:creationId xmlns:a16="http://schemas.microsoft.com/office/drawing/2014/main" id="{7C944648-48A6-4ACB-A484-5A405E582615}"/>
+                <a16:creationId xmlns:a16="http://schemas.microsoft.com/office/drawing/2014/main" id="{620B2206-A02A-48C6-84DD-691E31ABA520}"/>
               </a:ext>
             </a:extLst>
           </p:cNvPr>
@@ -8863,7 +8863,7 @@
           <p:cNvPr id="13" name="">
             <a:extLst xmlns:a="http://schemas.openxmlformats.org/drawingml/2006/main">
               <a:ext uri="{FF2B5EF4-FFF2-40B4-BE49-F238E27FC236}">
-                <a16:creationId xmlns:a16="http://schemas.microsoft.com/office/drawing/2014/main" id="{8DE7F40E-4698-4218-BB55-C648E0F7394D}"/>
+                <a16:creationId xmlns:a16="http://schemas.microsoft.com/office/drawing/2014/main" id="{5D3205CB-9A71-4FD3-B5AC-32FAAF6623ED}"/>
               </a:ext>
             </a:extLst>
           </p:cNvPr>
@@ -8921,7 +8921,7 @@
           <p:cNvPr id="14" name="">
             <a:extLst xmlns:a="http://schemas.openxmlformats.org/drawingml/2006/main">
               <a:ext uri="{FF2B5EF4-FFF2-40B4-BE49-F238E27FC236}">
-                <a16:creationId xmlns:a16="http://schemas.microsoft.com/office/drawing/2014/main" id="{134F2F09-E370-4584-857F-F4BE10619BA7}"/>
+                <a16:creationId xmlns:a16="http://schemas.microsoft.com/office/drawing/2014/main" id="{63CB118C-DAF6-4566-8356-F65968CF2C29}"/>
               </a:ext>
             </a:extLst>
           </p:cNvPr>
@@ -8979,7 +8979,7 @@
           <p:cNvPr id="15" name="">
             <a:extLst xmlns:a="http://schemas.openxmlformats.org/drawingml/2006/main">
               <a:ext uri="{FF2B5EF4-FFF2-40B4-BE49-F238E27FC236}">
-                <a16:creationId xmlns:a16="http://schemas.microsoft.com/office/drawing/2014/main" id="{08B940DA-9CF9-48EE-9293-5A17122852AB}"/>
+                <a16:creationId xmlns:a16="http://schemas.microsoft.com/office/drawing/2014/main" id="{F244F69C-7EEE-4E7B-BA76-1231DF79193E}"/>
               </a:ext>
             </a:extLst>
           </p:cNvPr>
@@ -9037,7 +9037,7 @@
           <p:cNvPr id="16" name="">
             <a:extLst xmlns:a="http://schemas.openxmlformats.org/drawingml/2006/main">
               <a:ext uri="{FF2B5EF4-FFF2-40B4-BE49-F238E27FC236}">
-                <a16:creationId xmlns:a16="http://schemas.microsoft.com/office/drawing/2014/main" id="{947C0D76-7C0D-4E3F-9937-747D04A314B3}"/>
+                <a16:creationId xmlns:a16="http://schemas.microsoft.com/office/drawing/2014/main" id="{2E37EA53-5566-4C6F-9FF7-A37CDF511F8D}"/>
               </a:ext>
             </a:extLst>
           </p:cNvPr>
@@ -9095,7 +9095,7 @@
           <p:cNvPr id="17" name="">
             <a:extLst xmlns:a="http://schemas.openxmlformats.org/drawingml/2006/main">
               <a:ext uri="{FF2B5EF4-FFF2-40B4-BE49-F238E27FC236}">
-                <a16:creationId xmlns:a16="http://schemas.microsoft.com/office/drawing/2014/main" id="{60345701-1C49-4463-B61E-2461DCC9C8FD}"/>
+                <a16:creationId xmlns:a16="http://schemas.microsoft.com/office/drawing/2014/main" id="{5EB88A9F-C780-4DF8-95A2-E38F49F1E5AA}"/>
               </a:ext>
             </a:extLst>
           </p:cNvPr>
@@ -9153,7 +9153,7 @@
           <p:cNvPr id="18" name="">
             <a:extLst xmlns:a="http://schemas.openxmlformats.org/drawingml/2006/main">
               <a:ext uri="{FF2B5EF4-FFF2-40B4-BE49-F238E27FC236}">
-                <a16:creationId xmlns:a16="http://schemas.microsoft.com/office/drawing/2014/main" id="{819153C3-F2DD-41DC-8772-31DA2A85EBF9}"/>
+                <a16:creationId xmlns:a16="http://schemas.microsoft.com/office/drawing/2014/main" id="{28B35ABB-8F56-4EF8-97C2-17A19BDF242B}"/>
               </a:ext>
             </a:extLst>
           </p:cNvPr>
@@ -9186,7 +9186,7 @@
           <p:cNvPr id="19" name="">
             <a:extLst xmlns:a="http://schemas.openxmlformats.org/drawingml/2006/main">
               <a:ext uri="{FF2B5EF4-FFF2-40B4-BE49-F238E27FC236}">
-                <a16:creationId xmlns:a16="http://schemas.microsoft.com/office/drawing/2014/main" id="{740814A9-7787-41FE-BCD3-AF1F45DA681C}"/>
+                <a16:creationId xmlns:a16="http://schemas.microsoft.com/office/drawing/2014/main" id="{7C83BDCB-48E2-4FA8-B944-57F6096AD4B5}"/>
               </a:ext>
             </a:extLst>
           </p:cNvPr>
@@ -9242,7 +9242,7 @@
     </p:spTree>
     <p:extLst>
       <p:ext uri="{BB962C8B-B14F-4D97-AF65-F5344CB8AC3E}">
-        <p14:creationId xmlns:p14="http://schemas.microsoft.com/office/powerpoint/2010/main" val="897162402"/>
+        <p14:creationId xmlns:p14="http://schemas.microsoft.com/office/powerpoint/2010/main" val="1695554518"/>
       </p:ext>
     </p:extLst>
   </p:cSld>

</xml_diff>